<commit_message>
feat(presentation): add "Take it with you" scan-to-explore QR slide to gRPC decks
Mirrors the REST decks: left QR -> the gRPC site, right QR -> the Workshops &
Tutorials hub. Added to deck.js source for all three decks (100, python,
quarkus) and rebuilt the r1.1 pptx. New QR assets qr-grpc-site.png and qr-hub.png.
</commit_message>
<xml_diff>
--- a/presentation/api-patterns-grpc-python/api-patterns-grpc-python-r1.1.pptx
+++ b/presentation/api-patterns-grpc-python/api-patterns-grpc-python-r1.1.pptx
@@ -73,9 +73,10 @@
     <p:sldId id="321" r:id="rId67"/>
     <p:sldId id="322" r:id="rId68"/>
     <p:sldId id="323" r:id="rId69"/>
+    <p:sldId id="324" r:id="rId70"/>
   </p:sldIdLst>
   <p:notesMasterIdLst>
-    <p:notesMasterId r:id="rId70"/>
+    <p:notesMasterId r:id="rId71"/>
   </p:notesMasterIdLst>
   <p:sldSz cx="12192000" cy="6858000"/>
   <p:notesSz cx="6858000" cy="12192000"/>
@@ -6225,6 +6226,94 @@
             <a:fld id="{F7021451-1387-4CA6-816F-3879F97B5CBC}" type="slidenum">
               <a:rPr lang="en-US"/>
               <a:t>68</a:t>
+            </a:fld>
+            <a:endParaRPr lang="en-US"/>
+          </a:p>
+        </p:txBody>
+      </p:sp>
+    </p:spTree>
+    <p:extLst>
+      <p:ext uri="{BB962C8B-B14F-4D97-AF65-F5344CB8AC3E}">
+        <p14:creationId xmlns:p14="http://schemas.microsoft.com/office/powerpoint/2010/main" val="1024086991"/>
+      </p:ext>
+    </p:extLst>
+  </p:cSld>
+  <p:clrMapOvr>
+    <a:masterClrMapping/>
+  </p:clrMapOvr>
+</p:notes>
+</file>
+
+<file path=ppt/notesSlides/notesSlide69.xml><?xml version="1.0" encoding="utf-8"?>
+<p:notes xmlns:a="http://schemas.openxmlformats.org/drawingml/2006/main" xmlns:r="http://schemas.openxmlformats.org/officeDocument/2006/relationships" xmlns:p="http://schemas.openxmlformats.org/presentationml/2006/main">
+  <p:cSld>
+    <p:spTree>
+      <p:nvGrpSpPr>
+        <p:cNvPr id="1" name=""/>
+        <p:cNvGrpSpPr/>
+        <p:nvPr/>
+      </p:nvGrpSpPr>
+      <p:grpSpPr>
+        <a:xfrm>
+          <a:off x="0" y="0"/>
+          <a:ext cx="0" cy="0"/>
+          <a:chOff x="0" y="0"/>
+          <a:chExt cx="0" cy="0"/>
+        </a:xfrm>
+      </p:grpSpPr>
+      <p:sp>
+        <p:nvSpPr>
+          <p:cNvPr id="2" name="Slide Image Placeholder 1"/>
+          <p:cNvSpPr>
+            <a:spLocks noGrp="1" noRot="1" noChangeAspect="1"/>
+          </p:cNvSpPr>
+          <p:nvPr>
+            <p:ph type="sldImg"/>
+          </p:nvPr>
+        </p:nvSpPr>
+        <p:spPr/>
+      </p:sp>
+      <p:sp>
+        <p:nvSpPr>
+          <p:cNvPr id="3" name="Notes Placeholder 2"/>
+          <p:cNvSpPr>
+            <a:spLocks noGrp="1"/>
+          </p:cNvSpPr>
+          <p:nvPr>
+            <p:ph type="body" idx="1"/>
+          </p:nvPr>
+        </p:nvSpPr>
+        <p:spPr/>
+        <p:txBody>
+          <a:bodyPr/>
+          <a:lstStyle/>
+          <a:p>
+            <a:r>
+              <a:rPr lang="en-US" dirty="0"/>
+              <a:t>This is the Python implementation deck, so the left code takes you to the runnable Python example and contract, the right to the whole series. On the left, the site: the chapters, the Protobuf contracts, and the runnable both-stack examples, all public. On the right, the Workshops and Tutorials hub: every workshop, tutorial, and deck in the series in one place, including the REST, GraphQL, and WebSockets siblings. Scan whichever is useful; both are on the Pattern Catalyst GitHub organization.</a:t>
+            </a:r>
+            <a:endParaRPr lang="en-US" dirty="0"/>
+          </a:p>
+        </p:txBody>
+      </p:sp>
+      <p:sp>
+        <p:nvSpPr>
+          <p:cNvPr id="4" name="Slide Number Placeholder 3"/>
+          <p:cNvSpPr>
+            <a:spLocks noGrp="1"/>
+          </p:cNvSpPr>
+          <p:nvPr>
+            <p:ph type="sldNum" sz="quarter" idx="10"/>
+          </p:nvPr>
+        </p:nvSpPr>
+        <p:spPr/>
+        <p:txBody>
+          <a:bodyPr/>
+          <a:lstStyle/>
+          <a:p>
+            <a:fld id="{F7021451-1387-4CA6-816F-3879F97B5CBC}" type="slidenum">
+              <a:rPr lang="en-US"/>
+              <a:t>69</a:t>
             </a:fld>
             <a:endParaRPr lang="en-US"/>
           </a:p>
@@ -6840,7 +6929,7 @@
       </p:grpSpPr>
       <p:pic>
         <p:nvPicPr>
-          <p:cNvPr id="2" name="Image 0" descr="/home/rsedor/Dev/api-patterns-and-practices-grpc/presentation/_shared/assets/cover-panel.png">    </p:cNvPr>
+          <p:cNvPr id="2" name="Image 0" descr="/tmp/pcwork/api-patterns-and-practices-grpc/presentation/_shared/assets/cover-panel.png">    </p:cNvPr>
           <p:cNvPicPr>
             <a:picLocks noChangeAspect="1"/>
           </p:cNvPicPr>
@@ -7093,7 +7182,7 @@
       </p:sp>
       <p:pic>
         <p:nvPicPr>
-          <p:cNvPr id="8" name="Image 1" descr="/home/rsedor/Dev/api-patterns-and-practices-grpc/presentation/_shared/assets/logo-candidate-2.png">    </p:cNvPr>
+          <p:cNvPr id="8" name="Image 1" descr="/tmp/pcwork/api-patterns-and-practices-grpc/presentation/_shared/assets/logo-candidate-2.png">    </p:cNvPr>
           <p:cNvPicPr>
             <a:picLocks noChangeAspect="1"/>
           </p:cNvPicPr>
@@ -7149,7 +7238,7 @@
       </p:grpSpPr>
       <p:pic>
         <p:nvPicPr>
-          <p:cNvPr id="2" name="Image 0" descr="/home/rsedor/Dev/api-patterns-and-practices-grpc/presentation/_shared/assets/section-panel.png">    </p:cNvPr>
+          <p:cNvPr id="2" name="Image 0" descr="/tmp/pcwork/api-patterns-and-practices-grpc/presentation/_shared/assets/section-panel.png">    </p:cNvPr>
           <p:cNvPicPr>
             <a:picLocks noChangeAspect="1"/>
           </p:cNvPicPr>
@@ -7290,7 +7379,7 @@
       </p:sp>
       <p:pic>
         <p:nvPicPr>
-          <p:cNvPr id="6" name="Image 1" descr="/home/rsedor/Dev/api-patterns-and-practices-grpc/presentation/_shared/assets/redhat-logo-white.png">    </p:cNvPr>
+          <p:cNvPr id="6" name="Image 1" descr="/tmp/pcwork/api-patterns-and-practices-grpc/presentation/_shared/assets/redhat-logo-white.png">    </p:cNvPr>
           <p:cNvPicPr>
             <a:picLocks noChangeAspect="1"/>
           </p:cNvPicPr>
@@ -7378,7 +7467,7 @@
       </p:sp>
       <p:pic>
         <p:nvPicPr>
-          <p:cNvPr id="3" name="Image 0" descr="/home/rsedor/Dev/api-patterns-and-practices-grpc/presentation/_shared/assets/logo-candidate-2.png">    </p:cNvPr>
+          <p:cNvPr id="3" name="Image 0" descr="/tmp/pcwork/api-patterns-and-practices-grpc/presentation/_shared/assets/logo-candidate-2.png">    </p:cNvPr>
           <p:cNvPicPr>
             <a:picLocks noChangeAspect="1"/>
           </p:cNvPicPr>
@@ -7480,7 +7569,7 @@
       </p:sp>
       <p:pic>
         <p:nvPicPr>
-          <p:cNvPr id="6" name="Image 1" descr="/home/rsedor/Dev/api-patterns-and-practices-grpc/presentation/_shared/png/07-unary-stub-to-stub.png">    </p:cNvPr>
+          <p:cNvPr id="6" name="Image 1" descr="/tmp/pcwork/api-patterns-and-practices-grpc/presentation/_shared/png/07-unary-stub-to-stub.png">    </p:cNvPr>
           <p:cNvPicPr>
             <a:picLocks noChangeAspect="1"/>
           </p:cNvPicPr>
@@ -7606,7 +7695,7 @@
       </p:sp>
       <p:pic>
         <p:nvPicPr>
-          <p:cNvPr id="3" name="Image 0" descr="/home/rsedor/Dev/api-patterns-and-practices-grpc/presentation/_shared/assets/logo-candidate-2.png">    </p:cNvPr>
+          <p:cNvPr id="3" name="Image 0" descr="/tmp/pcwork/api-patterns-and-practices-grpc/presentation/_shared/assets/logo-candidate-2.png">    </p:cNvPr>
           <p:cNvPicPr>
             <a:picLocks noChangeAspect="1"/>
           </p:cNvPicPr>
@@ -8210,7 +8299,7 @@
       </p:grpSpPr>
       <p:pic>
         <p:nvPicPr>
-          <p:cNvPr id="2" name="Image 0" descr="/home/rsedor/Dev/api-patterns-and-practices-grpc/presentation/_shared/assets/section-panel.png">    </p:cNvPr>
+          <p:cNvPr id="2" name="Image 0" descr="/tmp/pcwork/api-patterns-and-practices-grpc/presentation/_shared/assets/section-panel.png">    </p:cNvPr>
           <p:cNvPicPr>
             <a:picLocks noChangeAspect="1"/>
           </p:cNvPicPr>
@@ -8351,7 +8440,7 @@
       </p:sp>
       <p:pic>
         <p:nvPicPr>
-          <p:cNvPr id="6" name="Image 1" descr="/home/rsedor/Dev/api-patterns-and-practices-grpc/presentation/_shared/assets/redhat-logo-white.png">    </p:cNvPr>
+          <p:cNvPr id="6" name="Image 1" descr="/tmp/pcwork/api-patterns-and-practices-grpc/presentation/_shared/assets/redhat-logo-white.png">    </p:cNvPr>
           <p:cNvPicPr>
             <a:picLocks noChangeAspect="1"/>
           </p:cNvPicPr>
@@ -8439,7 +8528,7 @@
       </p:sp>
       <p:pic>
         <p:nvPicPr>
-          <p:cNvPr id="3" name="Image 0" descr="/home/rsedor/Dev/api-patterns-and-practices-grpc/presentation/_shared/assets/logo-candidate-2.png">    </p:cNvPr>
+          <p:cNvPr id="3" name="Image 0" descr="/tmp/pcwork/api-patterns-and-practices-grpc/presentation/_shared/assets/logo-candidate-2.png">    </p:cNvPr>
           <p:cNvPicPr>
             <a:picLocks noChangeAspect="1"/>
           </p:cNvPicPr>
@@ -8541,7 +8630,7 @@
       </p:sp>
       <p:pic>
         <p:nvPicPr>
-          <p:cNvPr id="6" name="Image 1" descr="/home/rsedor/Dev/api-patterns-and-practices-grpc/presentation/_shared/png/09-client-bidi-streaming.png">    </p:cNvPr>
+          <p:cNvPr id="6" name="Image 1" descr="/tmp/pcwork/api-patterns-and-practices-grpc/presentation/_shared/png/09-client-bidi-streaming.png">    </p:cNvPr>
           <p:cNvPicPr>
             <a:picLocks noChangeAspect="1"/>
           </p:cNvPicPr>
@@ -8667,7 +8756,7 @@
       </p:sp>
       <p:pic>
         <p:nvPicPr>
-          <p:cNvPr id="3" name="Image 0" descr="/home/rsedor/Dev/api-patterns-and-practices-grpc/presentation/_shared/assets/logo-candidate-2.png">    </p:cNvPr>
+          <p:cNvPr id="3" name="Image 0" descr="/tmp/pcwork/api-patterns-and-practices-grpc/presentation/_shared/assets/logo-candidate-2.png">    </p:cNvPr>
           <p:cNvPicPr>
             <a:picLocks noChangeAspect="1"/>
           </p:cNvPicPr>
@@ -9213,7 +9302,7 @@
       </p:sp>
       <p:pic>
         <p:nvPicPr>
-          <p:cNvPr id="3" name="Image 0" descr="/home/rsedor/Dev/api-patterns-and-practices-grpc/presentation/_shared/assets/logo-candidate-2.png">    </p:cNvPr>
+          <p:cNvPr id="3" name="Image 0" descr="/tmp/pcwork/api-patterns-and-practices-grpc/presentation/_shared/assets/logo-candidate-2.png">    </p:cNvPr>
           <p:cNvPicPr>
             <a:picLocks noChangeAspect="1"/>
           </p:cNvPicPr>
@@ -9745,7 +9834,7 @@
       </p:grpSpPr>
       <p:pic>
         <p:nvPicPr>
-          <p:cNvPr id="2" name="Image 0" descr="/home/rsedor/Dev/api-patterns-and-practices-grpc/presentation/_shared/assets/section-panel.png">    </p:cNvPr>
+          <p:cNvPr id="2" name="Image 0" descr="/tmp/pcwork/api-patterns-and-practices-grpc/presentation/_shared/assets/section-panel.png">    </p:cNvPr>
           <p:cNvPicPr>
             <a:picLocks noChangeAspect="1"/>
           </p:cNvPicPr>
@@ -9886,7 +9975,7 @@
       </p:sp>
       <p:pic>
         <p:nvPicPr>
-          <p:cNvPr id="6" name="Image 1" descr="/home/rsedor/Dev/api-patterns-and-practices-grpc/presentation/_shared/assets/redhat-logo-white.png">    </p:cNvPr>
+          <p:cNvPr id="6" name="Image 1" descr="/tmp/pcwork/api-patterns-and-practices-grpc/presentation/_shared/assets/redhat-logo-white.png">    </p:cNvPr>
           <p:cNvPicPr>
             <a:picLocks noChangeAspect="1"/>
           </p:cNvPicPr>
@@ -9974,7 +10063,7 @@
       </p:sp>
       <p:pic>
         <p:nvPicPr>
-          <p:cNvPr id="3" name="Image 0" descr="/home/rsedor/Dev/api-patterns-and-practices-grpc/presentation/_shared/assets/logo-candidate-2.png">    </p:cNvPr>
+          <p:cNvPr id="3" name="Image 0" descr="/tmp/pcwork/api-patterns-and-practices-grpc/presentation/_shared/assets/logo-candidate-2.png">    </p:cNvPr>
           <p:cNvPicPr>
             <a:picLocks noChangeAspect="1"/>
           </p:cNvPicPr>
@@ -10076,7 +10165,7 @@
       </p:sp>
       <p:pic>
         <p:nvPicPr>
-          <p:cNvPr id="6" name="Image 1" descr="/home/rsedor/Dev/api-patterns-and-practices-grpc/presentation/_shared/png/11-rich-error-model.png">    </p:cNvPr>
+          <p:cNvPr id="6" name="Image 1" descr="/tmp/pcwork/api-patterns-and-practices-grpc/presentation/_shared/png/11-rich-error-model.png">    </p:cNvPr>
           <p:cNvPicPr>
             <a:picLocks noChangeAspect="1"/>
           </p:cNvPicPr>
@@ -10202,7 +10291,7 @@
       </p:sp>
       <p:pic>
         <p:nvPicPr>
-          <p:cNvPr id="3" name="Image 0" descr="/home/rsedor/Dev/api-patterns-and-practices-grpc/presentation/_shared/assets/logo-candidate-2.png">    </p:cNvPr>
+          <p:cNvPr id="3" name="Image 0" descr="/tmp/pcwork/api-patterns-and-practices-grpc/presentation/_shared/assets/logo-candidate-2.png">    </p:cNvPr>
           <p:cNvPicPr>
             <a:picLocks noChangeAspect="1"/>
           </p:cNvPicPr>
@@ -10712,7 +10801,7 @@
       </p:sp>
       <p:pic>
         <p:nvPicPr>
-          <p:cNvPr id="3" name="Image 0" descr="/home/rsedor/Dev/api-patterns-and-practices-grpc/presentation/_shared/assets/logo-candidate-2.png">    </p:cNvPr>
+          <p:cNvPr id="3" name="Image 0" descr="/tmp/pcwork/api-patterns-and-practices-grpc/presentation/_shared/assets/logo-candidate-2.png">    </p:cNvPr>
           <p:cNvPicPr>
             <a:picLocks noChangeAspect="1"/>
           </p:cNvPicPr>
@@ -11210,7 +11299,7 @@
       </p:sp>
       <p:pic>
         <p:nvPicPr>
-          <p:cNvPr id="3" name="Image 0" descr="/home/rsedor/Dev/api-patterns-and-practices-grpc/presentation/_shared/assets/logo-candidate-2.png">    </p:cNvPr>
+          <p:cNvPr id="3" name="Image 0" descr="/tmp/pcwork/api-patterns-and-practices-grpc/presentation/_shared/assets/logo-candidate-2.png">    </p:cNvPr>
           <p:cNvPicPr>
             <a:picLocks noChangeAspect="1"/>
           </p:cNvPicPr>
@@ -11724,7 +11813,7 @@
       </p:grpSpPr>
       <p:pic>
         <p:nvPicPr>
-          <p:cNvPr id="2" name="Image 0" descr="/home/rsedor/Dev/api-patterns-and-practices-grpc/presentation/_shared/assets/section-panel.png">    </p:cNvPr>
+          <p:cNvPr id="2" name="Image 0" descr="/tmp/pcwork/api-patterns-and-practices-grpc/presentation/_shared/assets/section-panel.png">    </p:cNvPr>
           <p:cNvPicPr>
             <a:picLocks noChangeAspect="1"/>
           </p:cNvPicPr>
@@ -11865,7 +11954,7 @@
       </p:sp>
       <p:pic>
         <p:nvPicPr>
-          <p:cNvPr id="6" name="Image 1" descr="/home/rsedor/Dev/api-patterns-and-practices-grpc/presentation/_shared/assets/redhat-logo-white.png">    </p:cNvPr>
+          <p:cNvPr id="6" name="Image 1" descr="/tmp/pcwork/api-patterns-and-practices-grpc/presentation/_shared/assets/redhat-logo-white.png">    </p:cNvPr>
           <p:cNvPicPr>
             <a:picLocks noChangeAspect="1"/>
           </p:cNvPicPr>
@@ -11953,7 +12042,7 @@
       </p:sp>
       <p:pic>
         <p:nvPicPr>
-          <p:cNvPr id="3" name="Image 0" descr="/home/rsedor/Dev/api-patterns-and-practices-grpc/presentation/_shared/assets/logo-candidate-2.png">    </p:cNvPr>
+          <p:cNvPr id="3" name="Image 0" descr="/tmp/pcwork/api-patterns-and-practices-grpc/presentation/_shared/assets/logo-candidate-2.png">    </p:cNvPr>
           <p:cNvPicPr>
             <a:picLocks noChangeAspect="1"/>
           </p:cNvPicPr>
@@ -12055,7 +12144,7 @@
       </p:sp>
       <p:pic>
         <p:nvPicPr>
-          <p:cNvPr id="6" name="Image 1" descr="/home/rsedor/Dev/api-patterns-and-practices-grpc/presentation/_shared/png/13-fieldmask-projection.png">    </p:cNvPr>
+          <p:cNvPr id="6" name="Image 1" descr="/tmp/pcwork/api-patterns-and-practices-grpc/presentation/_shared/png/13-fieldmask-projection.png">    </p:cNvPr>
           <p:cNvPicPr>
             <a:picLocks noChangeAspect="1"/>
           </p:cNvPicPr>
@@ -12181,7 +12270,7 @@
       </p:sp>
       <p:pic>
         <p:nvPicPr>
-          <p:cNvPr id="3" name="Image 0" descr="/home/rsedor/Dev/api-patterns-and-practices-grpc/presentation/_shared/assets/logo-candidate-2.png">    </p:cNvPr>
+          <p:cNvPr id="3" name="Image 0" descr="/tmp/pcwork/api-patterns-and-practices-grpc/presentation/_shared/assets/logo-candidate-2.png">    </p:cNvPr>
           <p:cNvPicPr>
             <a:picLocks noChangeAspect="1"/>
           </p:cNvPicPr>
@@ -12799,7 +12888,7 @@
       </p:sp>
       <p:pic>
         <p:nvPicPr>
-          <p:cNvPr id="3" name="Image 0" descr="/home/rsedor/Dev/api-patterns-and-practices-grpc/presentation/_shared/assets/logo-candidate-2.png">    </p:cNvPr>
+          <p:cNvPr id="3" name="Image 0" descr="/tmp/pcwork/api-patterns-and-practices-grpc/presentation/_shared/assets/logo-candidate-2.png">    </p:cNvPr>
           <p:cNvPicPr>
             <a:picLocks noChangeAspect="1"/>
           </p:cNvPicPr>
@@ -12901,7 +12990,7 @@
       </p:sp>
       <p:pic>
         <p:nvPicPr>
-          <p:cNvPr id="6" name="Image 1" descr="/home/rsedor/Dev/api-patterns-and-practices-grpc/presentation/_shared/png/14-buf-breaking-gate.png">    </p:cNvPr>
+          <p:cNvPr id="6" name="Image 1" descr="/tmp/pcwork/api-patterns-and-practices-grpc/presentation/_shared/png/14-buf-breaking-gate.png">    </p:cNvPr>
           <p:cNvPicPr>
             <a:picLocks noChangeAspect="1"/>
           </p:cNvPicPr>
@@ -12995,7 +13084,7 @@
       </p:grpSpPr>
       <p:pic>
         <p:nvPicPr>
-          <p:cNvPr id="2" name="Image 0" descr="/home/rsedor/Dev/api-patterns-and-practices-grpc/presentation/_shared/assets/section-panel.png">    </p:cNvPr>
+          <p:cNvPr id="2" name="Image 0" descr="/tmp/pcwork/api-patterns-and-practices-grpc/presentation/_shared/assets/section-panel.png">    </p:cNvPr>
           <p:cNvPicPr>
             <a:picLocks noChangeAspect="1"/>
           </p:cNvPicPr>
@@ -13136,7 +13225,7 @@
       </p:sp>
       <p:pic>
         <p:nvPicPr>
-          <p:cNvPr id="6" name="Image 1" descr="/home/rsedor/Dev/api-patterns-and-practices-grpc/presentation/_shared/assets/redhat-logo-white.png">    </p:cNvPr>
+          <p:cNvPr id="6" name="Image 1" descr="/tmp/pcwork/api-patterns-and-practices-grpc/presentation/_shared/assets/redhat-logo-white.png">    </p:cNvPr>
           <p:cNvPicPr>
             <a:picLocks noChangeAspect="1"/>
           </p:cNvPicPr>
@@ -13224,7 +13313,7 @@
       </p:sp>
       <p:pic>
         <p:nvPicPr>
-          <p:cNvPr id="3" name="Image 0" descr="/home/rsedor/Dev/api-patterns-and-practices-grpc/presentation/_shared/assets/logo-candidate-2.png">    </p:cNvPr>
+          <p:cNvPr id="3" name="Image 0" descr="/tmp/pcwork/api-patterns-and-practices-grpc/presentation/_shared/assets/logo-candidate-2.png">    </p:cNvPr>
           <p:cNvPicPr>
             <a:picLocks noChangeAspect="1"/>
           </p:cNvPicPr>
@@ -13326,7 +13415,7 @@
       </p:sp>
       <p:pic>
         <p:nvPicPr>
-          <p:cNvPr id="6" name="Image 1" descr="/home/rsedor/Dev/api-patterns-and-practices-grpc/presentation/_shared/png/15-python-gil-concurrency.png">    </p:cNvPr>
+          <p:cNvPr id="6" name="Image 1" descr="/tmp/pcwork/api-patterns-and-practices-grpc/presentation/_shared/png/15-python-gil-concurrency.png">    </p:cNvPr>
           <p:cNvPicPr>
             <a:picLocks noChangeAspect="1"/>
           </p:cNvPicPr>
@@ -13452,7 +13541,7 @@
       </p:sp>
       <p:pic>
         <p:nvPicPr>
-          <p:cNvPr id="3" name="Image 0" descr="/home/rsedor/Dev/api-patterns-and-practices-grpc/presentation/_shared/assets/logo-candidate-2.png">    </p:cNvPr>
+          <p:cNvPr id="3" name="Image 0" descr="/tmp/pcwork/api-patterns-and-practices-grpc/presentation/_shared/assets/logo-candidate-2.png">    </p:cNvPr>
           <p:cNvPicPr>
             <a:picLocks noChangeAspect="1"/>
           </p:cNvPicPr>
@@ -13554,7 +13643,7 @@
       </p:sp>
       <p:pic>
         <p:nvPicPr>
-          <p:cNvPr id="6" name="Image 1" descr="/home/rsedor/Dev/api-patterns-and-practices-grpc/presentation/_shared/png/15-thread-exhaustion-overlap.png">    </p:cNvPr>
+          <p:cNvPr id="6" name="Image 1" descr="/tmp/pcwork/api-patterns-and-practices-grpc/presentation/_shared/png/15-thread-exhaustion-overlap.png">    </p:cNvPr>
           <p:cNvPicPr>
             <a:picLocks noChangeAspect="1"/>
           </p:cNvPicPr>
@@ -13680,7 +13769,7 @@
       </p:sp>
       <p:pic>
         <p:nvPicPr>
-          <p:cNvPr id="3" name="Image 0" descr="/home/rsedor/Dev/api-patterns-and-practices-grpc/presentation/_shared/assets/logo-candidate-2.png">    </p:cNvPr>
+          <p:cNvPr id="3" name="Image 0" descr="/tmp/pcwork/api-patterns-and-practices-grpc/presentation/_shared/assets/logo-candidate-2.png">    </p:cNvPr>
           <p:cNvPicPr>
             <a:picLocks noChangeAspect="1"/>
           </p:cNvPicPr>
@@ -14248,7 +14337,7 @@
       </p:grpSpPr>
       <p:pic>
         <p:nvPicPr>
-          <p:cNvPr id="2" name="Image 0" descr="/home/rsedor/Dev/api-patterns-and-practices-grpc/presentation/_shared/assets/section-panel.png">    </p:cNvPr>
+          <p:cNvPr id="2" name="Image 0" descr="/tmp/pcwork/api-patterns-and-practices-grpc/presentation/_shared/assets/section-panel.png">    </p:cNvPr>
           <p:cNvPicPr>
             <a:picLocks noChangeAspect="1"/>
           </p:cNvPicPr>
@@ -14389,7 +14478,7 @@
       </p:sp>
       <p:pic>
         <p:nvPicPr>
-          <p:cNvPr id="6" name="Image 1" descr="/home/rsedor/Dev/api-patterns-and-practices-grpc/presentation/_shared/assets/redhat-logo-white.png">    </p:cNvPr>
+          <p:cNvPr id="6" name="Image 1" descr="/tmp/pcwork/api-patterns-and-practices-grpc/presentation/_shared/assets/redhat-logo-white.png">    </p:cNvPr>
           <p:cNvPicPr>
             <a:picLocks noChangeAspect="1"/>
           </p:cNvPicPr>
@@ -14477,7 +14566,7 @@
       </p:sp>
       <p:pic>
         <p:nvPicPr>
-          <p:cNvPr id="3" name="Image 0" descr="/home/rsedor/Dev/api-patterns-and-practices-grpc/presentation/_shared/assets/logo-candidate-2.png">    </p:cNvPr>
+          <p:cNvPr id="3" name="Image 0" descr="/tmp/pcwork/api-patterns-and-practices-grpc/presentation/_shared/assets/logo-candidate-2.png">    </p:cNvPr>
           <p:cNvPicPr>
             <a:picLocks noChangeAspect="1"/>
           </p:cNvPicPr>
@@ -14800,7 +14889,7 @@
       </p:sp>
       <p:pic>
         <p:nvPicPr>
-          <p:cNvPr id="3" name="Image 0" descr="/home/rsedor/Dev/api-patterns-and-practices-grpc/presentation/_shared/assets/logo-candidate-2.png">    </p:cNvPr>
+          <p:cNvPr id="3" name="Image 0" descr="/tmp/pcwork/api-patterns-and-practices-grpc/presentation/_shared/assets/logo-candidate-2.png">    </p:cNvPr>
           <p:cNvPicPr>
             <a:picLocks noChangeAspect="1"/>
           </p:cNvPicPr>
@@ -14902,7 +14991,7 @@
       </p:sp>
       <p:pic>
         <p:nvPicPr>
-          <p:cNvPr id="6" name="Image 1" descr="/home/rsedor/Dev/api-patterns-and-practices-grpc/presentation/_shared/png/16-operation-lifecycle.png">    </p:cNvPr>
+          <p:cNvPr id="6" name="Image 1" descr="/tmp/pcwork/api-patterns-and-practices-grpc/presentation/_shared/png/16-operation-lifecycle.png">    </p:cNvPr>
           <p:cNvPicPr>
             <a:picLocks noChangeAspect="1"/>
           </p:cNvPicPr>
@@ -15028,7 +15117,7 @@
       </p:sp>
       <p:pic>
         <p:nvPicPr>
-          <p:cNvPr id="3" name="Image 0" descr="/home/rsedor/Dev/api-patterns-and-practices-grpc/presentation/_shared/assets/logo-candidate-2.png">    </p:cNvPr>
+          <p:cNvPr id="3" name="Image 0" descr="/tmp/pcwork/api-patterns-and-practices-grpc/presentation/_shared/assets/logo-candidate-2.png">    </p:cNvPr>
           <p:cNvPicPr>
             <a:picLocks noChangeAspect="1"/>
           </p:cNvPicPr>
@@ -15704,7 +15793,7 @@
       </p:grpSpPr>
       <p:pic>
         <p:nvPicPr>
-          <p:cNvPr id="2" name="Image 0" descr="/home/rsedor/Dev/api-patterns-and-practices-grpc/presentation/_shared/assets/section-panel.png">    </p:cNvPr>
+          <p:cNvPr id="2" name="Image 0" descr="/tmp/pcwork/api-patterns-and-practices-grpc/presentation/_shared/assets/section-panel.png">    </p:cNvPr>
           <p:cNvPicPr>
             <a:picLocks noChangeAspect="1"/>
           </p:cNvPicPr>
@@ -15845,7 +15934,7 @@
       </p:sp>
       <p:pic>
         <p:nvPicPr>
-          <p:cNvPr id="6" name="Image 1" descr="/home/rsedor/Dev/api-patterns-and-practices-grpc/presentation/_shared/assets/redhat-logo-white.png">    </p:cNvPr>
+          <p:cNvPr id="6" name="Image 1" descr="/tmp/pcwork/api-patterns-and-practices-grpc/presentation/_shared/assets/redhat-logo-white.png">    </p:cNvPr>
           <p:cNvPicPr>
             <a:picLocks noChangeAspect="1"/>
           </p:cNvPicPr>
@@ -15933,7 +16022,7 @@
       </p:sp>
       <p:pic>
         <p:nvPicPr>
-          <p:cNvPr id="3" name="Image 0" descr="/home/rsedor/Dev/api-patterns-and-practices-grpc/presentation/_shared/assets/logo-candidate-2.png">    </p:cNvPr>
+          <p:cNvPr id="3" name="Image 0" descr="/tmp/pcwork/api-patterns-and-practices-grpc/presentation/_shared/assets/logo-candidate-2.png">    </p:cNvPr>
           <p:cNvPicPr>
             <a:picLocks noChangeAspect="1"/>
           </p:cNvPicPr>
@@ -16035,7 +16124,7 @@
       </p:sp>
       <p:pic>
         <p:nvPicPr>
-          <p:cNvPr id="6" name="Image 1" descr="/home/rsedor/Dev/api-patterns-and-practices-grpc/presentation/_shared/png/17-slow-consumer-backpressure.png">    </p:cNvPr>
+          <p:cNvPr id="6" name="Image 1" descr="/tmp/pcwork/api-patterns-and-practices-grpc/presentation/_shared/png/17-slow-consumer-backpressure.png">    </p:cNvPr>
           <p:cNvPicPr>
             <a:picLocks noChangeAspect="1"/>
           </p:cNvPicPr>
@@ -16161,7 +16250,7 @@
       </p:sp>
       <p:pic>
         <p:nvPicPr>
-          <p:cNvPr id="3" name="Image 0" descr="/home/rsedor/Dev/api-patterns-and-practices-grpc/presentation/_shared/assets/logo-candidate-2.png">    </p:cNvPr>
+          <p:cNvPr id="3" name="Image 0" descr="/tmp/pcwork/api-patterns-and-practices-grpc/presentation/_shared/assets/logo-candidate-2.png">    </p:cNvPr>
           <p:cNvPicPr>
             <a:picLocks noChangeAspect="1"/>
           </p:cNvPicPr>
@@ -16853,7 +16942,7 @@
       </p:grpSpPr>
       <p:pic>
         <p:nvPicPr>
-          <p:cNvPr id="2" name="Image 0" descr="/home/rsedor/Dev/api-patterns-and-practices-grpc/presentation/_shared/assets/section-panel.png">    </p:cNvPr>
+          <p:cNvPr id="2" name="Image 0" descr="/tmp/pcwork/api-patterns-and-practices-grpc/presentation/_shared/assets/section-panel.png">    </p:cNvPr>
           <p:cNvPicPr>
             <a:picLocks noChangeAspect="1"/>
           </p:cNvPicPr>
@@ -16994,7 +17083,7 @@
       </p:sp>
       <p:pic>
         <p:nvPicPr>
-          <p:cNvPr id="6" name="Image 1" descr="/home/rsedor/Dev/api-patterns-and-practices-grpc/presentation/_shared/assets/redhat-logo-white.png">    </p:cNvPr>
+          <p:cNvPr id="6" name="Image 1" descr="/tmp/pcwork/api-patterns-and-practices-grpc/presentation/_shared/assets/redhat-logo-white.png">    </p:cNvPr>
           <p:cNvPicPr>
             <a:picLocks noChangeAspect="1"/>
           </p:cNvPicPr>
@@ -17082,7 +17171,7 @@
       </p:sp>
       <p:pic>
         <p:nvPicPr>
-          <p:cNvPr id="3" name="Image 0" descr="/home/rsedor/Dev/api-patterns-and-practices-grpc/presentation/_shared/assets/logo-candidate-2.png">    </p:cNvPr>
+          <p:cNvPr id="3" name="Image 0" descr="/tmp/pcwork/api-patterns-and-practices-grpc/presentation/_shared/assets/logo-candidate-2.png">    </p:cNvPr>
           <p:cNvPicPr>
             <a:picLocks noChangeAspect="1"/>
           </p:cNvPicPr>
@@ -17184,7 +17273,7 @@
       </p:sp>
       <p:pic>
         <p:nvPicPr>
-          <p:cNvPr id="6" name="Image 1" descr="/home/rsedor/Dev/api-patterns-and-practices-grpc/presentation/_shared/png/19-mtls-mutual-verification.png">    </p:cNvPr>
+          <p:cNvPr id="6" name="Image 1" descr="/tmp/pcwork/api-patterns-and-practices-grpc/presentation/_shared/png/19-mtls-mutual-verification.png">    </p:cNvPr>
           <p:cNvPicPr>
             <a:picLocks noChangeAspect="1"/>
           </p:cNvPicPr>
@@ -17310,7 +17399,7 @@
       </p:sp>
       <p:pic>
         <p:nvPicPr>
-          <p:cNvPr id="3" name="Image 0" descr="/home/rsedor/Dev/api-patterns-and-practices-grpc/presentation/_shared/assets/logo-candidate-2.png">    </p:cNvPr>
+          <p:cNvPr id="3" name="Image 0" descr="/tmp/pcwork/api-patterns-and-practices-grpc/presentation/_shared/assets/logo-candidate-2.png">    </p:cNvPr>
           <p:cNvPicPr>
             <a:picLocks noChangeAspect="1"/>
           </p:cNvPicPr>
@@ -17860,7 +17949,7 @@
       </p:grpSpPr>
       <p:pic>
         <p:nvPicPr>
-          <p:cNvPr id="2" name="Image 0" descr="/home/rsedor/Dev/api-patterns-and-practices-grpc/presentation/_shared/assets/section-panel.png">    </p:cNvPr>
+          <p:cNvPr id="2" name="Image 0" descr="/tmp/pcwork/api-patterns-and-practices-grpc/presentation/_shared/assets/section-panel.png">    </p:cNvPr>
           <p:cNvPicPr>
             <a:picLocks noChangeAspect="1"/>
           </p:cNvPicPr>
@@ -18001,7 +18090,7 @@
       </p:sp>
       <p:pic>
         <p:nvPicPr>
-          <p:cNvPr id="6" name="Image 1" descr="/home/rsedor/Dev/api-patterns-and-practices-grpc/presentation/_shared/assets/redhat-logo-white.png">    </p:cNvPr>
+          <p:cNvPr id="6" name="Image 1" descr="/tmp/pcwork/api-patterns-and-practices-grpc/presentation/_shared/assets/redhat-logo-white.png">    </p:cNvPr>
           <p:cNvPicPr>
             <a:picLocks noChangeAspect="1"/>
           </p:cNvPicPr>
@@ -18089,7 +18178,7 @@
       </p:sp>
       <p:pic>
         <p:nvPicPr>
-          <p:cNvPr id="3" name="Image 0" descr="/home/rsedor/Dev/api-patterns-and-practices-grpc/presentation/_shared/assets/logo-candidate-2.png">    </p:cNvPr>
+          <p:cNvPr id="3" name="Image 0" descr="/tmp/pcwork/api-patterns-and-practices-grpc/presentation/_shared/assets/logo-candidate-2.png">    </p:cNvPr>
           <p:cNvPicPr>
             <a:picLocks noChangeAspect="1"/>
           </p:cNvPicPr>
@@ -18191,7 +18280,7 @@
       </p:sp>
       <p:pic>
         <p:nvPicPr>
-          <p:cNvPr id="6" name="Image 1" descr="/home/rsedor/Dev/api-patterns-and-practices-grpc/presentation/_shared/png/20-jwt-in-metadata-flow.png">    </p:cNvPr>
+          <p:cNvPr id="6" name="Image 1" descr="/tmp/pcwork/api-patterns-and-practices-grpc/presentation/_shared/png/20-jwt-in-metadata-flow.png">    </p:cNvPr>
           <p:cNvPicPr>
             <a:picLocks noChangeAspect="1"/>
           </p:cNvPicPr>
@@ -18285,7 +18374,7 @@
       </p:grpSpPr>
       <p:pic>
         <p:nvPicPr>
-          <p:cNvPr id="2" name="Image 0" descr="/home/rsedor/Dev/api-patterns-and-practices-grpc/presentation/_shared/assets/section-panel.png">    </p:cNvPr>
+          <p:cNvPr id="2" name="Image 0" descr="/tmp/pcwork/api-patterns-and-practices-grpc/presentation/_shared/assets/section-panel.png">    </p:cNvPr>
           <p:cNvPicPr>
             <a:picLocks noChangeAspect="1"/>
           </p:cNvPicPr>
@@ -18426,7 +18515,7 @@
       </p:sp>
       <p:pic>
         <p:nvPicPr>
-          <p:cNvPr id="6" name="Image 1" descr="/home/rsedor/Dev/api-patterns-and-practices-grpc/presentation/_shared/assets/redhat-logo-white.png">    </p:cNvPr>
+          <p:cNvPr id="6" name="Image 1" descr="/tmp/pcwork/api-patterns-and-practices-grpc/presentation/_shared/assets/redhat-logo-white.png">    </p:cNvPr>
           <p:cNvPicPr>
             <a:picLocks noChangeAspect="1"/>
           </p:cNvPicPr>
@@ -18514,7 +18603,7 @@
       </p:sp>
       <p:pic>
         <p:nvPicPr>
-          <p:cNvPr id="3" name="Image 0" descr="/home/rsedor/Dev/api-patterns-and-practices-grpc/presentation/_shared/assets/logo-candidate-2.png">    </p:cNvPr>
+          <p:cNvPr id="3" name="Image 0" descr="/tmp/pcwork/api-patterns-and-practices-grpc/presentation/_shared/assets/logo-candidate-2.png">    </p:cNvPr>
           <p:cNvPicPr>
             <a:picLocks noChangeAspect="1"/>
           </p:cNvPicPr>
@@ -19208,7 +19297,7 @@
       </p:grpSpPr>
       <p:pic>
         <p:nvPicPr>
-          <p:cNvPr id="2" name="Image 0" descr="/home/rsedor/Dev/api-patterns-and-practices-grpc/presentation/_shared/assets/section-panel.png">    </p:cNvPr>
+          <p:cNvPr id="2" name="Image 0" descr="/tmp/pcwork/api-patterns-and-practices-grpc/presentation/_shared/assets/section-panel.png">    </p:cNvPr>
           <p:cNvPicPr>
             <a:picLocks noChangeAspect="1"/>
           </p:cNvPicPr>
@@ -19349,7 +19438,7 @@
       </p:sp>
       <p:pic>
         <p:nvPicPr>
-          <p:cNvPr id="6" name="Image 1" descr="/home/rsedor/Dev/api-patterns-and-practices-grpc/presentation/_shared/assets/redhat-logo-white.png">    </p:cNvPr>
+          <p:cNvPr id="6" name="Image 1" descr="/tmp/pcwork/api-patterns-and-practices-grpc/presentation/_shared/assets/redhat-logo-white.png">    </p:cNvPr>
           <p:cNvPicPr>
             <a:picLocks noChangeAspect="1"/>
           </p:cNvPicPr>
@@ -19437,7 +19526,7 @@
       </p:sp>
       <p:pic>
         <p:nvPicPr>
-          <p:cNvPr id="3" name="Image 0" descr="/home/rsedor/Dev/api-patterns-and-practices-grpc/presentation/_shared/assets/logo-candidate-2.png">    </p:cNvPr>
+          <p:cNvPr id="3" name="Image 0" descr="/tmp/pcwork/api-patterns-and-practices-grpc/presentation/_shared/assets/logo-candidate-2.png">    </p:cNvPr>
           <p:cNvPicPr>
             <a:picLocks noChangeAspect="1"/>
           </p:cNvPicPr>
@@ -19539,7 +19628,7 @@
       </p:sp>
       <p:pic>
         <p:nvPicPr>
-          <p:cNvPr id="6" name="Image 1" descr="/home/rsedor/Dev/api-patterns-and-practices-grpc/presentation/_shared/png/21-observability-surfaces.png">    </p:cNvPr>
+          <p:cNvPr id="6" name="Image 1" descr="/tmp/pcwork/api-patterns-and-practices-grpc/presentation/_shared/png/21-observability-surfaces.png">    </p:cNvPr>
           <p:cNvPicPr>
             <a:picLocks noChangeAspect="1"/>
           </p:cNvPicPr>
@@ -19665,7 +19754,7 @@
       </p:sp>
       <p:pic>
         <p:nvPicPr>
-          <p:cNvPr id="3" name="Image 0" descr="/home/rsedor/Dev/api-patterns-and-practices-grpc/presentation/_shared/assets/logo-candidate-2.png">    </p:cNvPr>
+          <p:cNvPr id="3" name="Image 0" descr="/tmp/pcwork/api-patterns-and-practices-grpc/presentation/_shared/assets/logo-candidate-2.png">    </p:cNvPr>
           <p:cNvPicPr>
             <a:picLocks noChangeAspect="1"/>
           </p:cNvPicPr>
@@ -20359,7 +20448,7 @@
       </p:grpSpPr>
       <p:pic>
         <p:nvPicPr>
-          <p:cNvPr id="2" name="Image 0" descr="/home/rsedor/Dev/api-patterns-and-practices-grpc/presentation/_shared/assets/section-panel.png">    </p:cNvPr>
+          <p:cNvPr id="2" name="Image 0" descr="/tmp/pcwork/api-patterns-and-practices-grpc/presentation/_shared/assets/section-panel.png">    </p:cNvPr>
           <p:cNvPicPr>
             <a:picLocks noChangeAspect="1"/>
           </p:cNvPicPr>
@@ -20500,7 +20589,7 @@
       </p:sp>
       <p:pic>
         <p:nvPicPr>
-          <p:cNvPr id="6" name="Image 1" descr="/home/rsedor/Dev/api-patterns-and-practices-grpc/presentation/_shared/assets/redhat-logo-white.png">    </p:cNvPr>
+          <p:cNvPr id="6" name="Image 1" descr="/tmp/pcwork/api-patterns-and-practices-grpc/presentation/_shared/assets/redhat-logo-white.png">    </p:cNvPr>
           <p:cNvPicPr>
             <a:picLocks noChangeAspect="1"/>
           </p:cNvPicPr>
@@ -20588,7 +20677,7 @@
       </p:sp>
       <p:pic>
         <p:nvPicPr>
-          <p:cNvPr id="3" name="Image 0" descr="/home/rsedor/Dev/api-patterns-and-practices-grpc/presentation/_shared/assets/logo-candidate-2.png">    </p:cNvPr>
+          <p:cNvPr id="3" name="Image 0" descr="/tmp/pcwork/api-patterns-and-practices-grpc/presentation/_shared/assets/logo-candidate-2.png">    </p:cNvPr>
           <p:cNvPicPr>
             <a:picLocks noChangeAspect="1"/>
           </p:cNvPicPr>
@@ -20690,7 +20779,7 @@
       </p:sp>
       <p:pic>
         <p:nvPicPr>
-          <p:cNvPr id="6" name="Image 1" descr="/home/rsedor/Dev/api-patterns-and-practices-grpc/presentation/_shared/png/22-grpc-lb-problem.png">    </p:cNvPr>
+          <p:cNvPr id="6" name="Image 1" descr="/tmp/pcwork/api-patterns-and-practices-grpc/presentation/_shared/png/22-grpc-lb-problem.png">    </p:cNvPr>
           <p:cNvPicPr>
             <a:picLocks noChangeAspect="1"/>
           </p:cNvPicPr>
@@ -20816,7 +20905,7 @@
       </p:sp>
       <p:pic>
         <p:nvPicPr>
-          <p:cNvPr id="3" name="Image 0" descr="/home/rsedor/Dev/api-patterns-and-practices-grpc/presentation/_shared/assets/logo-candidate-2.png">    </p:cNvPr>
+          <p:cNvPr id="3" name="Image 0" descr="/tmp/pcwork/api-patterns-and-practices-grpc/presentation/_shared/assets/logo-candidate-2.png">    </p:cNvPr>
           <p:cNvPicPr>
             <a:picLocks noChangeAspect="1"/>
           </p:cNvPicPr>
@@ -21416,7 +21505,7 @@
       </p:sp>
       <p:pic>
         <p:nvPicPr>
-          <p:cNvPr id="3" name="Image 0" descr="/home/rsedor/Dev/api-patterns-and-practices-grpc/presentation/_shared/assets/logo-candidate-2.png">    </p:cNvPr>
+          <p:cNvPr id="3" name="Image 0" descr="/tmp/pcwork/api-patterns-and-practices-grpc/presentation/_shared/assets/logo-candidate-2.png">    </p:cNvPr>
           <p:cNvPicPr>
             <a:picLocks noChangeAspect="1"/>
           </p:cNvPicPr>
@@ -21518,7 +21607,7 @@
       </p:sp>
       <p:pic>
         <p:nvPicPr>
-          <p:cNvPr id="6" name="Image 1" descr="/home/rsedor/Dev/api-patterns-and-practices-grpc/presentation/_shared/png/23-grpc-web-framing.png">    </p:cNvPr>
+          <p:cNvPr id="6" name="Image 1" descr="/tmp/pcwork/api-patterns-and-practices-grpc/presentation/_shared/png/23-grpc-web-framing.png">    </p:cNvPr>
           <p:cNvPicPr>
             <a:picLocks noChangeAspect="1"/>
           </p:cNvPicPr>
@@ -21644,7 +21733,7 @@
       </p:sp>
       <p:pic>
         <p:nvPicPr>
-          <p:cNvPr id="3" name="Image 0" descr="/home/rsedor/Dev/api-patterns-and-practices-grpc/presentation/_shared/assets/logo-candidate-2.png">    </p:cNvPr>
+          <p:cNvPr id="3" name="Image 0" descr="/tmp/pcwork/api-patterns-and-practices-grpc/presentation/_shared/assets/logo-candidate-2.png">    </p:cNvPr>
           <p:cNvPicPr>
             <a:picLocks noChangeAspect="1"/>
           </p:cNvPicPr>
@@ -22248,7 +22337,7 @@
       </p:grpSpPr>
       <p:pic>
         <p:nvPicPr>
-          <p:cNvPr id="2" name="Image 0" descr="/home/rsedor/Dev/api-patterns-and-practices-grpc/presentation/_shared/assets/section-panel.png">    </p:cNvPr>
+          <p:cNvPr id="2" name="Image 0" descr="/tmp/pcwork/api-patterns-and-practices-grpc/presentation/_shared/assets/section-panel.png">    </p:cNvPr>
           <p:cNvPicPr>
             <a:picLocks noChangeAspect="1"/>
           </p:cNvPicPr>
@@ -22389,7 +22478,7 @@
       </p:sp>
       <p:pic>
         <p:nvPicPr>
-          <p:cNvPr id="6" name="Image 1" descr="/home/rsedor/Dev/api-patterns-and-practices-grpc/presentation/_shared/assets/redhat-logo-white.png">    </p:cNvPr>
+          <p:cNvPr id="6" name="Image 1" descr="/tmp/pcwork/api-patterns-and-practices-grpc/presentation/_shared/assets/redhat-logo-white.png">    </p:cNvPr>
           <p:cNvPicPr>
             <a:picLocks noChangeAspect="1"/>
           </p:cNvPicPr>
@@ -22477,7 +22566,7 @@
       </p:sp>
       <p:pic>
         <p:nvPicPr>
-          <p:cNvPr id="3" name="Image 0" descr="/home/rsedor/Dev/api-patterns-and-practices-grpc/presentation/_shared/assets/logo-candidate-2.png">    </p:cNvPr>
+          <p:cNvPr id="3" name="Image 0" descr="/tmp/pcwork/api-patterns-and-practices-grpc/presentation/_shared/assets/logo-candidate-2.png">    </p:cNvPr>
           <p:cNvPicPr>
             <a:picLocks noChangeAspect="1"/>
           </p:cNvPicPr>
@@ -23095,7 +23184,7 @@
       </p:sp>
       <p:pic>
         <p:nvPicPr>
-          <p:cNvPr id="3" name="Image 0" descr="/home/rsedor/Dev/api-patterns-and-practices-grpc/presentation/_shared/assets/logo-candidate-2.png">    </p:cNvPr>
+          <p:cNvPr id="3" name="Image 0" descr="/tmp/pcwork/api-patterns-and-practices-grpc/presentation/_shared/assets/logo-candidate-2.png">    </p:cNvPr>
           <p:cNvPicPr>
             <a:picLocks noChangeAspect="1"/>
           </p:cNvPicPr>
@@ -23197,7 +23286,7 @@
       </p:sp>
       <p:pic>
         <p:nvPicPr>
-          <p:cNvPr id="6" name="Image 1" descr="/home/rsedor/Dev/api-patterns-and-practices-grpc/presentation/_shared/png/25-grpc-test-pyramid.png">    </p:cNvPr>
+          <p:cNvPr id="6" name="Image 1" descr="/tmp/pcwork/api-patterns-and-practices-grpc/presentation/_shared/png/25-grpc-test-pyramid.png">    </p:cNvPr>
           <p:cNvPicPr>
             <a:picLocks noChangeAspect="1"/>
           </p:cNvPicPr>
@@ -23323,7 +23412,7 @@
       </p:sp>
       <p:pic>
         <p:nvPicPr>
-          <p:cNvPr id="3" name="Image 0" descr="/home/rsedor/Dev/api-patterns-and-practices-grpc/presentation/_shared/assets/logo-candidate-2.png">    </p:cNvPr>
+          <p:cNvPr id="3" name="Image 0" descr="/tmp/pcwork/api-patterns-and-practices-grpc/presentation/_shared/assets/logo-candidate-2.png">    </p:cNvPr>
           <p:cNvPicPr>
             <a:picLocks noChangeAspect="1"/>
           </p:cNvPicPr>
@@ -23995,7 +24084,7 @@
       </p:sp>
       <p:pic>
         <p:nvPicPr>
-          <p:cNvPr id="3" name="Image 0" descr="/home/rsedor/Dev/api-patterns-and-practices-grpc/presentation/_shared/assets/logo-candidate-2.png">    </p:cNvPr>
+          <p:cNvPr id="3" name="Image 0" descr="/tmp/pcwork/api-patterns-and-practices-grpc/presentation/_shared/assets/logo-candidate-2.png">    </p:cNvPr>
           <p:cNvPicPr>
             <a:picLocks noChangeAspect="1"/>
           </p:cNvPicPr>
@@ -24545,7 +24634,7 @@
       </p:grpSpPr>
       <p:pic>
         <p:nvPicPr>
-          <p:cNvPr id="2" name="Image 0" descr="/home/rsedor/Dev/api-patterns-and-practices-grpc/presentation/_shared/assets/section-panel.png">    </p:cNvPr>
+          <p:cNvPr id="2" name="Image 0" descr="/tmp/pcwork/api-patterns-and-practices-grpc/presentation/_shared/assets/section-panel.png">    </p:cNvPr>
           <p:cNvPicPr>
             <a:picLocks noChangeAspect="1"/>
           </p:cNvPicPr>
@@ -24686,7 +24775,7 @@
       </p:sp>
       <p:pic>
         <p:nvPicPr>
-          <p:cNvPr id="6" name="Image 1" descr="/home/rsedor/Dev/api-patterns-and-practices-grpc/presentation/_shared/assets/redhat-logo-white.png">    </p:cNvPr>
+          <p:cNvPr id="6" name="Image 1" descr="/tmp/pcwork/api-patterns-and-practices-grpc/presentation/_shared/assets/redhat-logo-white.png">    </p:cNvPr>
           <p:cNvPicPr>
             <a:picLocks noChangeAspect="1"/>
           </p:cNvPicPr>
@@ -24774,7 +24863,7 @@
       </p:sp>
       <p:pic>
         <p:nvPicPr>
-          <p:cNvPr id="3" name="Image 0" descr="/home/rsedor/Dev/api-patterns-and-practices-grpc/presentation/_shared/assets/logo-candidate-2.png">    </p:cNvPr>
+          <p:cNvPr id="3" name="Image 0" descr="/tmp/pcwork/api-patterns-and-practices-grpc/presentation/_shared/assets/logo-candidate-2.png">    </p:cNvPr>
           <p:cNvPicPr>
             <a:picLocks noChangeAspect="1"/>
           </p:cNvPicPr>
@@ -24876,7 +24965,7 @@
       </p:sp>
       <p:pic>
         <p:nvPicPr>
-          <p:cNvPr id="6" name="Image 1" descr="/home/rsedor/Dev/api-patterns-and-practices-grpc/presentation/_shared/png/27-final-project-architecture.png">    </p:cNvPr>
+          <p:cNvPr id="6" name="Image 1" descr="/tmp/pcwork/api-patterns-and-practices-grpc/presentation/_shared/png/27-final-project-architecture.png">    </p:cNvPr>
           <p:cNvPicPr>
             <a:picLocks noChangeAspect="1"/>
           </p:cNvPicPr>
@@ -25002,7 +25091,7 @@
       </p:sp>
       <p:pic>
         <p:nvPicPr>
-          <p:cNvPr id="3" name="Image 0" descr="/home/rsedor/Dev/api-patterns-and-practices-grpc/presentation/_shared/assets/logo-candidate-2.png">    </p:cNvPr>
+          <p:cNvPr id="3" name="Image 0" descr="/tmp/pcwork/api-patterns-and-practices-grpc/presentation/_shared/assets/logo-candidate-2.png">    </p:cNvPr>
           <p:cNvPicPr>
             <a:picLocks noChangeAspect="1"/>
           </p:cNvPicPr>
@@ -25624,7 +25713,7 @@
       </p:grpSpPr>
       <p:pic>
         <p:nvPicPr>
-          <p:cNvPr id="2" name="Image 0" descr="/home/rsedor/Dev/api-patterns-and-practices-grpc/presentation/_shared/assets/section-panel.png">    </p:cNvPr>
+          <p:cNvPr id="2" name="Image 0" descr="/tmp/pcwork/api-patterns-and-practices-grpc/presentation/_shared/assets/section-panel.png">    </p:cNvPr>
           <p:cNvPicPr>
             <a:picLocks noChangeAspect="1"/>
           </p:cNvPicPr>
@@ -25765,7 +25854,7 @@
       </p:sp>
       <p:pic>
         <p:nvPicPr>
-          <p:cNvPr id="6" name="Image 1" descr="/home/rsedor/Dev/api-patterns-and-practices-grpc/presentation/_shared/assets/redhat-logo-white.png">    </p:cNvPr>
+          <p:cNvPr id="6" name="Image 1" descr="/tmp/pcwork/api-patterns-and-practices-grpc/presentation/_shared/assets/redhat-logo-white.png">    </p:cNvPr>
           <p:cNvPicPr>
             <a:picLocks noChangeAspect="1"/>
           </p:cNvPicPr>
@@ -25853,7 +25942,7 @@
       </p:sp>
       <p:pic>
         <p:nvPicPr>
-          <p:cNvPr id="3" name="Image 0" descr="/home/rsedor/Dev/api-patterns-and-practices-grpc/presentation/_shared/assets/logo-candidate-2.png">    </p:cNvPr>
+          <p:cNvPr id="3" name="Image 0" descr="/tmp/pcwork/api-patterns-and-practices-grpc/presentation/_shared/assets/logo-candidate-2.png">    </p:cNvPr>
           <p:cNvPicPr>
             <a:picLocks noChangeAspect="1"/>
           </p:cNvPicPr>
@@ -26303,7 +26392,7 @@
       </p:sp>
       <p:pic>
         <p:nvPicPr>
-          <p:cNvPr id="3" name="Image 0" descr="/home/rsedor/Dev/api-patterns-and-practices-grpc/presentation/_shared/assets/logo-candidate-2.png">    </p:cNvPr>
+          <p:cNvPr id="3" name="Image 0" descr="/tmp/pcwork/api-patterns-and-practices-grpc/presentation/_shared/assets/logo-candidate-2.png">    </p:cNvPr>
           <p:cNvPicPr>
             <a:picLocks noChangeAspect="1"/>
           </p:cNvPicPr>
@@ -26579,7 +26668,7 @@
       </p:grpSpPr>
       <p:pic>
         <p:nvPicPr>
-          <p:cNvPr id="2" name="Image 0" descr="/home/rsedor/Dev/api-patterns-and-practices-grpc/presentation/_shared/assets/section-panel.png">    </p:cNvPr>
+          <p:cNvPr id="2" name="Image 0" descr="/tmp/pcwork/api-patterns-and-practices-grpc/presentation/_shared/assets/section-panel.png">    </p:cNvPr>
           <p:cNvPicPr>
             <a:picLocks noChangeAspect="1"/>
           </p:cNvPicPr>
@@ -26720,7 +26809,7 @@
       </p:sp>
       <p:pic>
         <p:nvPicPr>
-          <p:cNvPr id="6" name="Image 1" descr="/home/rsedor/Dev/api-patterns-and-practices-grpc/presentation/_shared/assets/redhat-logo-white.png">    </p:cNvPr>
+          <p:cNvPr id="6" name="Image 1" descr="/tmp/pcwork/api-patterns-and-practices-grpc/presentation/_shared/assets/redhat-logo-white.png">    </p:cNvPr>
           <p:cNvPicPr>
             <a:picLocks noChangeAspect="1"/>
           </p:cNvPicPr>
@@ -26808,7 +26897,7 @@
       </p:sp>
       <p:pic>
         <p:nvPicPr>
-          <p:cNvPr id="3" name="Image 0" descr="/home/rsedor/Dev/api-patterns-and-practices-grpc/presentation/_shared/assets/logo-candidate-2.png">    </p:cNvPr>
+          <p:cNvPr id="3" name="Image 0" descr="/tmp/pcwork/api-patterns-and-practices-grpc/presentation/_shared/assets/logo-candidate-2.png">    </p:cNvPr>
           <p:cNvPicPr>
             <a:picLocks noChangeAspect="1"/>
           </p:cNvPicPr>
@@ -27316,7 +27405,7 @@
       </p:sp>
       <p:pic>
         <p:nvPicPr>
-          <p:cNvPr id="3" name="Image 0" descr="/home/rsedor/Dev/api-patterns-and-practices-grpc/presentation/_shared/assets/logo-candidate-2.png">    </p:cNvPr>
+          <p:cNvPr id="3" name="Image 0" descr="/tmp/pcwork/api-patterns-and-practices-grpc/presentation/_shared/assets/logo-candidate-2.png">    </p:cNvPr>
           <p:cNvPicPr>
             <a:picLocks noChangeAspect="1"/>
           </p:cNvPicPr>
@@ -28024,7 +28113,7 @@
       </p:sp>
       <p:pic>
         <p:nvPicPr>
-          <p:cNvPr id="3" name="Image 0" descr="/home/rsedor/Dev/api-patterns-and-practices-grpc/presentation/_shared/assets/logo-candidate-2.png">    </p:cNvPr>
+          <p:cNvPr id="3" name="Image 0" descr="/tmp/pcwork/api-patterns-and-practices-grpc/presentation/_shared/assets/logo-candidate-2.png">    </p:cNvPr>
           <p:cNvPicPr>
             <a:picLocks noChangeAspect="1"/>
           </p:cNvPicPr>
@@ -28750,7 +28839,7 @@
       </p:sp>
       <p:pic>
         <p:nvPicPr>
-          <p:cNvPr id="3" name="Image 0" descr="/home/rsedor/Dev/api-patterns-and-practices-grpc/presentation/_shared/assets/logo-candidate-2.png">    </p:cNvPr>
+          <p:cNvPr id="3" name="Image 0" descr="/tmp/pcwork/api-patterns-and-practices-grpc/presentation/_shared/assets/logo-candidate-2.png">    </p:cNvPr>
           <p:cNvPicPr>
             <a:picLocks noChangeAspect="1"/>
           </p:cNvPicPr>
@@ -29512,7 +29601,7 @@
       </p:sp>
       <p:pic>
         <p:nvPicPr>
-          <p:cNvPr id="3" name="Image 0" descr="/home/rsedor/Dev/api-patterns-and-practices-grpc/presentation/_shared/assets/logo-candidate-2.png">    </p:cNvPr>
+          <p:cNvPr id="3" name="Image 0" descr="/tmp/pcwork/api-patterns-and-practices-grpc/presentation/_shared/assets/logo-candidate-2.png">    </p:cNvPr>
           <p:cNvPicPr>
             <a:picLocks noChangeAspect="1"/>
           </p:cNvPicPr>
@@ -30076,7 +30165,7 @@
       </p:sp>
       <p:pic>
         <p:nvPicPr>
-          <p:cNvPr id="3" name="Image 0" descr="/home/rsedor/Dev/api-patterns-and-practices-grpc/presentation/_shared/assets/logo-candidate-2.png">    </p:cNvPr>
+          <p:cNvPr id="3" name="Image 0" descr="/tmp/pcwork/api-patterns-and-practices-grpc/presentation/_shared/assets/logo-candidate-2.png">    </p:cNvPr>
           <p:cNvPicPr>
             <a:picLocks noChangeAspect="1"/>
           </p:cNvPicPr>
@@ -30658,7 +30747,7 @@
       </p:sp>
       <p:pic>
         <p:nvPicPr>
-          <p:cNvPr id="3" name="Image 0" descr="/home/rsedor/Dev/api-patterns-and-practices-grpc/presentation/_shared/assets/logo-candidate-2.png">    </p:cNvPr>
+          <p:cNvPr id="3" name="Image 0" descr="/tmp/pcwork/api-patterns-and-practices-grpc/presentation/_shared/assets/logo-candidate-2.png">    </p:cNvPr>
           <p:cNvPicPr>
             <a:picLocks noChangeAspect="1"/>
           </p:cNvPicPr>
@@ -31240,7 +31329,7 @@
       </p:sp>
       <p:pic>
         <p:nvPicPr>
-          <p:cNvPr id="3" name="Image 0" descr="/home/rsedor/Dev/api-patterns-and-practices-grpc/presentation/_shared/assets/logo-candidate-2.png">    </p:cNvPr>
+          <p:cNvPr id="3" name="Image 0" descr="/tmp/pcwork/api-patterns-and-practices-grpc/presentation/_shared/assets/logo-candidate-2.png">    </p:cNvPr>
           <p:cNvPicPr>
             <a:picLocks noChangeAspect="1"/>
           </p:cNvPicPr>
@@ -32020,7 +32109,7 @@
       </p:sp>
       <p:pic>
         <p:nvPicPr>
-          <p:cNvPr id="3" name="Image 0" descr="/home/rsedor/Dev/api-patterns-and-practices-grpc/presentation/_shared/assets/logo-candidate-2.png">    </p:cNvPr>
+          <p:cNvPr id="3" name="Image 0" descr="/tmp/pcwork/api-patterns-and-practices-grpc/presentation/_shared/assets/logo-candidate-2.png">    </p:cNvPr>
           <p:cNvPicPr>
             <a:picLocks noChangeAspect="1"/>
           </p:cNvPicPr>
@@ -32328,7 +32417,7 @@
       </p:sp>
       <p:pic>
         <p:nvPicPr>
-          <p:cNvPr id="3" name="Image 0" descr="/home/rsedor/Dev/api-patterns-and-practices-grpc/presentation/_shared/assets/logo-candidate-2.png">    </p:cNvPr>
+          <p:cNvPr id="3" name="Image 0" descr="/tmp/pcwork/api-patterns-and-practices-grpc/presentation/_shared/assets/logo-candidate-2.png">    </p:cNvPr>
           <p:cNvPicPr>
             <a:picLocks noChangeAspect="1"/>
           </p:cNvPicPr>
@@ -32543,6 +32632,454 @@
               <a:t>This deck does not claim a Python run against OpenShift Local that hasn't been built; see the Quarkus sibling deck for the verified CRC walkthrough.</a:t>
             </a:r>
             <a:endParaRPr lang="en-US" sz="1500" dirty="0"/>
+          </a:p>
+        </p:txBody>
+      </p:sp>
+    </p:spTree>
+  </p:cSld>
+  <p:clrMapOvr>
+    <a:masterClrMapping/>
+  </p:clrMapOvr>
+</p:sld>
+</file>
+
+<file path=ppt/slides/slide69.xml><?xml version="1.0" encoding="utf-8"?>
+<p:sld xmlns:a="http://schemas.openxmlformats.org/drawingml/2006/main" xmlns:r="http://schemas.openxmlformats.org/officeDocument/2006/relationships" xmlns:p="http://schemas.openxmlformats.org/presentationml/2006/main">
+  <p:cSld name="Slide 69">
+    <p:spTree>
+      <p:nvGrpSpPr>
+        <p:cNvPr id="1" name=""/>
+        <p:cNvGrpSpPr/>
+        <p:nvPr/>
+      </p:nvGrpSpPr>
+      <p:grpSpPr>
+        <a:xfrm>
+          <a:off x="0" y="0"/>
+          <a:ext cx="0" cy="0"/>
+          <a:chOff x="0" y="0"/>
+          <a:chExt cx="0" cy="0"/>
+        </a:xfrm>
+      </p:grpSpPr>
+      <p:sp>
+        <p:nvSpPr>
+          <p:cNvPr id="2" name="Text 0"/>
+          <p:cNvSpPr/>
+          <p:nvPr/>
+        </p:nvSpPr>
+        <p:spPr>
+          <a:xfrm>
+            <a:off x="566928" y="6364224"/>
+            <a:ext cx="914400" cy="274320"/>
+          </a:xfrm>
+          <a:prstGeom prst="rect">
+            <a:avLst/>
+          </a:prstGeom>
+          <a:noFill/>
+          <a:ln/>
+        </p:spPr>
+        <p:txBody>
+          <a:bodyPr wrap="square" rtlCol="0" anchor="ctr"/>
+          <a:lstStyle/>
+          <a:p>
+            <a:pPr algn="l" indent="0" marL="0">
+              <a:buNone/>
+            </a:pPr>
+            <a:r>
+              <a:rPr lang="en-US" sz="1000" dirty="0">
+                <a:solidFill>
+                  <a:srgbClr val="8A8A8A"/>
+                </a:solidFill>
+                <a:latin typeface="Red Hat Text" pitchFamily="34" charset="0"/>
+                <a:ea typeface="Red Hat Text" pitchFamily="34" charset="-122"/>
+                <a:cs typeface="Red Hat Text" pitchFamily="34" charset="-120"/>
+              </a:rPr>
+              <a:t>69</a:t>
+            </a:r>
+            <a:endParaRPr lang="en-US" sz="1000" dirty="0"/>
+          </a:p>
+        </p:txBody>
+      </p:sp>
+      <p:pic>
+        <p:nvPicPr>
+          <p:cNvPr id="3" name="Image 0" descr="/tmp/pcwork/api-patterns-and-practices-grpc/presentation/_shared/assets/logo-candidate-2.png">    </p:cNvPr>
+          <p:cNvPicPr>
+            <a:picLocks noChangeAspect="1"/>
+          </p:cNvPicPr>
+          <p:nvPr/>
+        </p:nvPicPr>
+        <p:blipFill>
+          <a:blip r:embed="rId1"/>
+          <a:stretch>
+            <a:fillRect/>
+          </a:stretch>
+        </p:blipFill>
+        <p:spPr>
+          <a:xfrm>
+            <a:off x="10561320" y="6355080"/>
+            <a:ext cx="1033272" cy="246888"/>
+          </a:xfrm>
+          <a:prstGeom prst="rect">
+            <a:avLst/>
+          </a:prstGeom>
+        </p:spPr>
+      </p:pic>
+      <p:sp>
+        <p:nvSpPr>
+          <p:cNvPr id="4" name="Text 1"/>
+          <p:cNvSpPr/>
+          <p:nvPr/>
+        </p:nvSpPr>
+        <p:spPr>
+          <a:xfrm>
+            <a:off x="566928" y="384048"/>
+            <a:ext cx="11055096" cy="292608"/>
+          </a:xfrm>
+          <a:prstGeom prst="rect">
+            <a:avLst/>
+          </a:prstGeom>
+          <a:noFill/>
+          <a:ln/>
+        </p:spPr>
+        <p:txBody>
+          <a:bodyPr wrap="square" rtlCol="0" anchor="ctr"/>
+          <a:lstStyle/>
+          <a:p>
+            <a:pPr algn="l" indent="0" marL="0">
+              <a:buNone/>
+            </a:pPr>
+            <a:r>
+              <a:rPr lang="en-US" sz="1200" b="1" spc="400" kern="0" dirty="0">
+                <a:solidFill>
+                  <a:srgbClr val="EE0000"/>
+                </a:solidFill>
+                <a:latin typeface="Overpass" pitchFamily="34" charset="0"/>
+                <a:ea typeface="Overpass" pitchFamily="34" charset="-122"/>
+                <a:cs typeface="Overpass" pitchFamily="34" charset="-120"/>
+              </a:rPr>
+              <a:t>SCAN TO EXPLORE</a:t>
+            </a:r>
+            <a:endParaRPr lang="en-US" sz="1200" dirty="0"/>
+          </a:p>
+        </p:txBody>
+      </p:sp>
+      <p:sp>
+        <p:nvSpPr>
+          <p:cNvPr id="5" name="Text 2"/>
+          <p:cNvSpPr/>
+          <p:nvPr/>
+        </p:nvSpPr>
+        <p:spPr>
+          <a:xfrm>
+            <a:off x="566928" y="676656"/>
+            <a:ext cx="11055096" cy="1005840"/>
+          </a:xfrm>
+          <a:prstGeom prst="rect">
+            <a:avLst/>
+          </a:prstGeom>
+          <a:noFill/>
+          <a:ln/>
+        </p:spPr>
+        <p:txBody>
+          <a:bodyPr wrap="square" rtlCol="0" anchor="t"/>
+          <a:lstStyle/>
+          <a:p>
+            <a:pPr algn="l" indent="0" marL="0">
+              <a:buNone/>
+            </a:pPr>
+            <a:r>
+              <a:rPr lang="en-US" sz="3000" b="1" dirty="0">
+                <a:solidFill>
+                  <a:srgbClr val="151515"/>
+                </a:solidFill>
+                <a:latin typeface="Overpass" pitchFamily="34" charset="0"/>
+                <a:ea typeface="Overpass" pitchFamily="34" charset="-122"/>
+                <a:cs typeface="Overpass" pitchFamily="34" charset="-120"/>
+              </a:rPr>
+              <a:t>Take it with you</a:t>
+            </a:r>
+            <a:endParaRPr lang="en-US" sz="3000" dirty="0"/>
+          </a:p>
+        </p:txBody>
+      </p:sp>
+      <p:pic>
+        <p:nvPicPr>
+          <p:cNvPr id="6" name="Image 1" descr="/tmp/pcwork/api-patterns-and-practices-grpc/presentation/_shared/assets/qr-grpc-site.png">    </p:cNvPr>
+          <p:cNvPicPr>
+            <a:picLocks noChangeAspect="1"/>
+          </p:cNvPicPr>
+          <p:nvPr/>
+        </p:nvPicPr>
+        <p:blipFill>
+          <a:blip r:embed="rId2"/>
+          <a:stretch>
+            <a:fillRect/>
+          </a:stretch>
+        </p:blipFill>
+        <p:spPr>
+          <a:xfrm>
+            <a:off x="2103120" y="1627632"/>
+            <a:ext cx="2834640" cy="2834640"/>
+          </a:xfrm>
+          <a:prstGeom prst="rect">
+            <a:avLst/>
+          </a:prstGeom>
+        </p:spPr>
+      </p:pic>
+      <p:sp>
+        <p:nvSpPr>
+          <p:cNvPr id="7" name="Text 3"/>
+          <p:cNvSpPr/>
+          <p:nvPr/>
+        </p:nvSpPr>
+        <p:spPr>
+          <a:xfrm>
+            <a:off x="1417320" y="4553712"/>
+            <a:ext cx="4206240" cy="365760"/>
+          </a:xfrm>
+          <a:prstGeom prst="rect">
+            <a:avLst/>
+          </a:prstGeom>
+          <a:noFill/>
+          <a:ln/>
+        </p:spPr>
+        <p:txBody>
+          <a:bodyPr wrap="square" rtlCol="0" anchor="ctr"/>
+          <a:lstStyle/>
+          <a:p>
+            <a:pPr algn="ctr" indent="0" marL="0">
+              <a:buNone/>
+            </a:pPr>
+            <a:r>
+              <a:rPr lang="en-US" sz="1800" b="1" dirty="0">
+                <a:solidFill>
+                  <a:srgbClr val="151515"/>
+                </a:solidFill>
+                <a:latin typeface="Overpass" pitchFamily="34" charset="0"/>
+                <a:ea typeface="Overpass" pitchFamily="34" charset="-122"/>
+                <a:cs typeface="Overpass" pitchFamily="34" charset="-120"/>
+              </a:rPr>
+              <a:t>The site</a:t>
+            </a:r>
+            <a:endParaRPr lang="en-US" sz="1800" dirty="0"/>
+          </a:p>
+        </p:txBody>
+      </p:sp>
+      <p:sp>
+        <p:nvSpPr>
+          <p:cNvPr id="8" name="Text 4"/>
+          <p:cNvSpPr/>
+          <p:nvPr/>
+        </p:nvSpPr>
+        <p:spPr>
+          <a:xfrm>
+            <a:off x="1325880" y="4937760"/>
+            <a:ext cx="4389120" cy="658368"/>
+          </a:xfrm>
+          <a:prstGeom prst="rect">
+            <a:avLst/>
+          </a:prstGeom>
+          <a:noFill/>
+          <a:ln/>
+        </p:spPr>
+        <p:txBody>
+          <a:bodyPr wrap="square" rtlCol="0" anchor="t"/>
+          <a:lstStyle/>
+          <a:p>
+            <a:pPr algn="ctr" indent="0" marL="0">
+              <a:buNone/>
+            </a:pPr>
+            <a:r>
+              <a:rPr lang="en-US" sz="1300" i="1" dirty="0">
+                <a:solidFill>
+                  <a:srgbClr val="5A5A5A"/>
+                </a:solidFill>
+                <a:latin typeface="Red Hat Text" pitchFamily="34" charset="0"/>
+                <a:ea typeface="Red Hat Text" pitchFamily="34" charset="-122"/>
+                <a:cs typeface="Red Hat Text" pitchFamily="34" charset="-120"/>
+              </a:rPr>
+              <a:t>Chapters, the Protobuf contracts, and both-stack runnable examples</a:t>
+            </a:r>
+            <a:endParaRPr lang="en-US" sz="1300" dirty="0"/>
+          </a:p>
+        </p:txBody>
+      </p:sp>
+      <p:sp>
+        <p:nvSpPr>
+          <p:cNvPr id="9" name="Text 5"/>
+          <p:cNvSpPr/>
+          <p:nvPr/>
+        </p:nvSpPr>
+        <p:spPr>
+          <a:xfrm>
+            <a:off x="1325880" y="5596128"/>
+            <a:ext cx="4389120" cy="292608"/>
+          </a:xfrm>
+          <a:prstGeom prst="rect">
+            <a:avLst/>
+          </a:prstGeom>
+          <a:noFill/>
+          <a:ln/>
+        </p:spPr>
+        <p:txBody>
+          <a:bodyPr wrap="square" rtlCol="0" anchor="ctr"/>
+          <a:lstStyle/>
+          <a:p>
+            <a:pPr algn="ctr" indent="0" marL="0">
+              <a:buNone/>
+            </a:pPr>
+            <a:r>
+              <a:rPr lang="en-US" sz="1000" dirty="0">
+                <a:solidFill>
+                  <a:srgbClr val="EE0000"/>
+                </a:solidFill>
+                <a:latin typeface="Red Hat Mono" pitchFamily="34" charset="0"/>
+                <a:ea typeface="Red Hat Mono" pitchFamily="34" charset="-122"/>
+                <a:cs typeface="Red Hat Mono" pitchFamily="34" charset="-120"/>
+              </a:rPr>
+              <a:t>patterncatalyst.github.io/api-patterns-and-practices-grpc</a:t>
+            </a:r>
+            <a:endParaRPr lang="en-US" sz="1000" dirty="0"/>
+          </a:p>
+        </p:txBody>
+      </p:sp>
+      <p:pic>
+        <p:nvPicPr>
+          <p:cNvPr id="10" name="Image 2" descr="/tmp/pcwork/api-patterns-and-practices-grpc/presentation/_shared/assets/qr-hub.png">    </p:cNvPr>
+          <p:cNvPicPr>
+            <a:picLocks noChangeAspect="1"/>
+          </p:cNvPicPr>
+          <p:nvPr/>
+        </p:nvPicPr>
+        <p:blipFill>
+          <a:blip r:embed="rId3"/>
+          <a:stretch>
+            <a:fillRect/>
+          </a:stretch>
+        </p:blipFill>
+        <p:spPr>
+          <a:xfrm>
+            <a:off x="7251192" y="1627632"/>
+            <a:ext cx="2834640" cy="2834640"/>
+          </a:xfrm>
+          <a:prstGeom prst="rect">
+            <a:avLst/>
+          </a:prstGeom>
+        </p:spPr>
+      </p:pic>
+      <p:sp>
+        <p:nvSpPr>
+          <p:cNvPr id="11" name="Text 6"/>
+          <p:cNvSpPr/>
+          <p:nvPr/>
+        </p:nvSpPr>
+        <p:spPr>
+          <a:xfrm>
+            <a:off x="6565392" y="4553712"/>
+            <a:ext cx="4206240" cy="365760"/>
+          </a:xfrm>
+          <a:prstGeom prst="rect">
+            <a:avLst/>
+          </a:prstGeom>
+          <a:noFill/>
+          <a:ln/>
+        </p:spPr>
+        <p:txBody>
+          <a:bodyPr wrap="square" rtlCol="0" anchor="ctr"/>
+          <a:lstStyle/>
+          <a:p>
+            <a:pPr algn="ctr" indent="0" marL="0">
+              <a:buNone/>
+            </a:pPr>
+            <a:r>
+              <a:rPr lang="en-US" sz="1800" b="1" dirty="0">
+                <a:solidFill>
+                  <a:srgbClr val="151515"/>
+                </a:solidFill>
+                <a:latin typeface="Overpass" pitchFamily="34" charset="0"/>
+                <a:ea typeface="Overpass" pitchFamily="34" charset="-122"/>
+                <a:cs typeface="Overpass" pitchFamily="34" charset="-120"/>
+              </a:rPr>
+              <a:t>Workshops &amp; Tutorials</a:t>
+            </a:r>
+            <a:endParaRPr lang="en-US" sz="1800" dirty="0"/>
+          </a:p>
+        </p:txBody>
+      </p:sp>
+      <p:sp>
+        <p:nvSpPr>
+          <p:cNvPr id="12" name="Text 7"/>
+          <p:cNvSpPr/>
+          <p:nvPr/>
+        </p:nvSpPr>
+        <p:spPr>
+          <a:xfrm>
+            <a:off x="6473952" y="4937760"/>
+            <a:ext cx="4389120" cy="658368"/>
+          </a:xfrm>
+          <a:prstGeom prst="rect">
+            <a:avLst/>
+          </a:prstGeom>
+          <a:noFill/>
+          <a:ln/>
+        </p:spPr>
+        <p:txBody>
+          <a:bodyPr wrap="square" rtlCol="0" anchor="t"/>
+          <a:lstStyle/>
+          <a:p>
+            <a:pPr algn="ctr" indent="0" marL="0">
+              <a:buNone/>
+            </a:pPr>
+            <a:r>
+              <a:rPr lang="en-US" sz="1300" i="1" dirty="0">
+                <a:solidFill>
+                  <a:srgbClr val="5A5A5A"/>
+                </a:solidFill>
+                <a:latin typeface="Red Hat Text" pitchFamily="34" charset="0"/>
+                <a:ea typeface="Red Hat Text" pitchFamily="34" charset="-122"/>
+                <a:cs typeface="Red Hat Text" pitchFamily="34" charset="-120"/>
+              </a:rPr>
+              <a:t>The whole series: every workshop, tutorial, and deck in one place</a:t>
+            </a:r>
+            <a:endParaRPr lang="en-US" sz="1300" dirty="0"/>
+          </a:p>
+        </p:txBody>
+      </p:sp>
+      <p:sp>
+        <p:nvSpPr>
+          <p:cNvPr id="13" name="Text 8"/>
+          <p:cNvSpPr/>
+          <p:nvPr/>
+        </p:nvSpPr>
+        <p:spPr>
+          <a:xfrm>
+            <a:off x="6473952" y="5596128"/>
+            <a:ext cx="4389120" cy="292608"/>
+          </a:xfrm>
+          <a:prstGeom prst="rect">
+            <a:avLst/>
+          </a:prstGeom>
+          <a:noFill/>
+          <a:ln/>
+        </p:spPr>
+        <p:txBody>
+          <a:bodyPr wrap="square" rtlCol="0" anchor="ctr"/>
+          <a:lstStyle/>
+          <a:p>
+            <a:pPr algn="ctr" indent="0" marL="0">
+              <a:buNone/>
+            </a:pPr>
+            <a:r>
+              <a:rPr lang="en-US" sz="900" dirty="0">
+                <a:solidFill>
+                  <a:srgbClr val="EE0000"/>
+                </a:solidFill>
+                <a:latin typeface="Red Hat Mono" pitchFamily="34" charset="0"/>
+                <a:ea typeface="Red Hat Mono" pitchFamily="34" charset="-122"/>
+                <a:cs typeface="Red Hat Mono" pitchFamily="34" charset="-120"/>
+              </a:rPr>
+              <a:t>patterncatalyst.github.io/patterncatalyst-workshops-tutorials-list</a:t>
+            </a:r>
+            <a:endParaRPr lang="en-US" sz="900" dirty="0"/>
           </a:p>
         </p:txBody>
       </p:sp>
@@ -32580,7 +33117,7 @@
       </p:grpSpPr>
       <p:pic>
         <p:nvPicPr>
-          <p:cNvPr id="2" name="Image 0" descr="/home/rsedor/Dev/api-patterns-and-practices-grpc/presentation/_shared/assets/section-panel.png">    </p:cNvPr>
+          <p:cNvPr id="2" name="Image 0" descr="/tmp/pcwork/api-patterns-and-practices-grpc/presentation/_shared/assets/section-panel.png">    </p:cNvPr>
           <p:cNvPicPr>
             <a:picLocks noChangeAspect="1"/>
           </p:cNvPicPr>
@@ -32721,7 +33258,7 @@
       </p:sp>
       <p:pic>
         <p:nvPicPr>
-          <p:cNvPr id="6" name="Image 1" descr="/home/rsedor/Dev/api-patterns-and-practices-grpc/presentation/_shared/assets/redhat-logo-white.png">    </p:cNvPr>
+          <p:cNvPr id="6" name="Image 1" descr="/tmp/pcwork/api-patterns-and-practices-grpc/presentation/_shared/assets/redhat-logo-white.png">    </p:cNvPr>
           <p:cNvPicPr>
             <a:picLocks noChangeAspect="1"/>
           </p:cNvPicPr>
@@ -32809,7 +33346,7 @@
       </p:sp>
       <p:pic>
         <p:nvPicPr>
-          <p:cNvPr id="3" name="Image 0" descr="/home/rsedor/Dev/api-patterns-and-practices-grpc/presentation/_shared/assets/logo-candidate-2.png">    </p:cNvPr>
+          <p:cNvPr id="3" name="Image 0" descr="/tmp/pcwork/api-patterns-and-practices-grpc/presentation/_shared/assets/logo-candidate-2.png">    </p:cNvPr>
           <p:cNvPicPr>
             <a:picLocks noChangeAspect="1"/>
           </p:cNvPicPr>
@@ -32911,7 +33448,7 @@
       </p:sp>
       <p:pic>
         <p:nvPicPr>
-          <p:cNvPr id="6" name="Image 1" descr="/home/rsedor/Dev/api-patterns-and-practices-grpc/presentation/_shared/png/04-wellknown-json-mapping.png">    </p:cNvPr>
+          <p:cNvPr id="6" name="Image 1" descr="/tmp/pcwork/api-patterns-and-practices-grpc/presentation/_shared/png/04-wellknown-json-mapping.png">    </p:cNvPr>
           <p:cNvPicPr>
             <a:picLocks noChangeAspect="1"/>
           </p:cNvPicPr>
@@ -33037,7 +33574,7 @@
       </p:sp>
       <p:pic>
         <p:nvPicPr>
-          <p:cNvPr id="3" name="Image 0" descr="/home/rsedor/Dev/api-patterns-and-practices-grpc/presentation/_shared/assets/logo-candidate-2.png">    </p:cNvPr>
+          <p:cNvPr id="3" name="Image 0" descr="/tmp/pcwork/api-patterns-and-practices-grpc/presentation/_shared/assets/logo-candidate-2.png">    </p:cNvPr>
           <p:cNvPicPr>
             <a:picLocks noChangeAspect="1"/>
           </p:cNvPicPr>

</xml_diff>

<commit_message>
feat(presentation): add "Take it with you" scan-to-explore QR slide to gRPC decks (#24)
Mirrors the REST decks: left QR -> the gRPC site, right QR -> the Workshops &
Tutorials hub. Added to deck.js source for all three decks (100, python,
quarkus) and rebuilt the r1.1 pptx. New QR assets qr-grpc-site.png and qr-hub.png.
</commit_message>
<xml_diff>
--- a/presentation/api-patterns-grpc-python/api-patterns-grpc-python-r1.1.pptx
+++ b/presentation/api-patterns-grpc-python/api-patterns-grpc-python-r1.1.pptx
@@ -73,9 +73,10 @@
     <p:sldId id="321" r:id="rId67"/>
     <p:sldId id="322" r:id="rId68"/>
     <p:sldId id="323" r:id="rId69"/>
+    <p:sldId id="324" r:id="rId70"/>
   </p:sldIdLst>
   <p:notesMasterIdLst>
-    <p:notesMasterId r:id="rId70"/>
+    <p:notesMasterId r:id="rId71"/>
   </p:notesMasterIdLst>
   <p:sldSz cx="12192000" cy="6858000"/>
   <p:notesSz cx="6858000" cy="12192000"/>
@@ -6225,6 +6226,94 @@
             <a:fld id="{F7021451-1387-4CA6-816F-3879F97B5CBC}" type="slidenum">
               <a:rPr lang="en-US"/>
               <a:t>68</a:t>
+            </a:fld>
+            <a:endParaRPr lang="en-US"/>
+          </a:p>
+        </p:txBody>
+      </p:sp>
+    </p:spTree>
+    <p:extLst>
+      <p:ext uri="{BB962C8B-B14F-4D97-AF65-F5344CB8AC3E}">
+        <p14:creationId xmlns:p14="http://schemas.microsoft.com/office/powerpoint/2010/main" val="1024086991"/>
+      </p:ext>
+    </p:extLst>
+  </p:cSld>
+  <p:clrMapOvr>
+    <a:masterClrMapping/>
+  </p:clrMapOvr>
+</p:notes>
+</file>
+
+<file path=ppt/notesSlides/notesSlide69.xml><?xml version="1.0" encoding="utf-8"?>
+<p:notes xmlns:a="http://schemas.openxmlformats.org/drawingml/2006/main" xmlns:r="http://schemas.openxmlformats.org/officeDocument/2006/relationships" xmlns:p="http://schemas.openxmlformats.org/presentationml/2006/main">
+  <p:cSld>
+    <p:spTree>
+      <p:nvGrpSpPr>
+        <p:cNvPr id="1" name=""/>
+        <p:cNvGrpSpPr/>
+        <p:nvPr/>
+      </p:nvGrpSpPr>
+      <p:grpSpPr>
+        <a:xfrm>
+          <a:off x="0" y="0"/>
+          <a:ext cx="0" cy="0"/>
+          <a:chOff x="0" y="0"/>
+          <a:chExt cx="0" cy="0"/>
+        </a:xfrm>
+      </p:grpSpPr>
+      <p:sp>
+        <p:nvSpPr>
+          <p:cNvPr id="2" name="Slide Image Placeholder 1"/>
+          <p:cNvSpPr>
+            <a:spLocks noGrp="1" noRot="1" noChangeAspect="1"/>
+          </p:cNvSpPr>
+          <p:nvPr>
+            <p:ph type="sldImg"/>
+          </p:nvPr>
+        </p:nvSpPr>
+        <p:spPr/>
+      </p:sp>
+      <p:sp>
+        <p:nvSpPr>
+          <p:cNvPr id="3" name="Notes Placeholder 2"/>
+          <p:cNvSpPr>
+            <a:spLocks noGrp="1"/>
+          </p:cNvSpPr>
+          <p:nvPr>
+            <p:ph type="body" idx="1"/>
+          </p:nvPr>
+        </p:nvSpPr>
+        <p:spPr/>
+        <p:txBody>
+          <a:bodyPr/>
+          <a:lstStyle/>
+          <a:p>
+            <a:r>
+              <a:rPr lang="en-US" dirty="0"/>
+              <a:t>This is the Python implementation deck, so the left code takes you to the runnable Python example and contract, the right to the whole series. On the left, the site: the chapters, the Protobuf contracts, and the runnable both-stack examples, all public. On the right, the Workshops and Tutorials hub: every workshop, tutorial, and deck in the series in one place, including the REST, GraphQL, and WebSockets siblings. Scan whichever is useful; both are on the Pattern Catalyst GitHub organization.</a:t>
+            </a:r>
+            <a:endParaRPr lang="en-US" dirty="0"/>
+          </a:p>
+        </p:txBody>
+      </p:sp>
+      <p:sp>
+        <p:nvSpPr>
+          <p:cNvPr id="4" name="Slide Number Placeholder 3"/>
+          <p:cNvSpPr>
+            <a:spLocks noGrp="1"/>
+          </p:cNvSpPr>
+          <p:nvPr>
+            <p:ph type="sldNum" sz="quarter" idx="10"/>
+          </p:nvPr>
+        </p:nvSpPr>
+        <p:spPr/>
+        <p:txBody>
+          <a:bodyPr/>
+          <a:lstStyle/>
+          <a:p>
+            <a:fld id="{F7021451-1387-4CA6-816F-3879F97B5CBC}" type="slidenum">
+              <a:rPr lang="en-US"/>
+              <a:t>69</a:t>
             </a:fld>
             <a:endParaRPr lang="en-US"/>
           </a:p>
@@ -6840,7 +6929,7 @@
       </p:grpSpPr>
       <p:pic>
         <p:nvPicPr>
-          <p:cNvPr id="2" name="Image 0" descr="/home/rsedor/Dev/api-patterns-and-practices-grpc/presentation/_shared/assets/cover-panel.png">    </p:cNvPr>
+          <p:cNvPr id="2" name="Image 0" descr="/tmp/pcwork/api-patterns-and-practices-grpc/presentation/_shared/assets/cover-panel.png">    </p:cNvPr>
           <p:cNvPicPr>
             <a:picLocks noChangeAspect="1"/>
           </p:cNvPicPr>
@@ -7093,7 +7182,7 @@
       </p:sp>
       <p:pic>
         <p:nvPicPr>
-          <p:cNvPr id="8" name="Image 1" descr="/home/rsedor/Dev/api-patterns-and-practices-grpc/presentation/_shared/assets/logo-candidate-2.png">    </p:cNvPr>
+          <p:cNvPr id="8" name="Image 1" descr="/tmp/pcwork/api-patterns-and-practices-grpc/presentation/_shared/assets/logo-candidate-2.png">    </p:cNvPr>
           <p:cNvPicPr>
             <a:picLocks noChangeAspect="1"/>
           </p:cNvPicPr>
@@ -7149,7 +7238,7 @@
       </p:grpSpPr>
       <p:pic>
         <p:nvPicPr>
-          <p:cNvPr id="2" name="Image 0" descr="/home/rsedor/Dev/api-patterns-and-practices-grpc/presentation/_shared/assets/section-panel.png">    </p:cNvPr>
+          <p:cNvPr id="2" name="Image 0" descr="/tmp/pcwork/api-patterns-and-practices-grpc/presentation/_shared/assets/section-panel.png">    </p:cNvPr>
           <p:cNvPicPr>
             <a:picLocks noChangeAspect="1"/>
           </p:cNvPicPr>
@@ -7290,7 +7379,7 @@
       </p:sp>
       <p:pic>
         <p:nvPicPr>
-          <p:cNvPr id="6" name="Image 1" descr="/home/rsedor/Dev/api-patterns-and-practices-grpc/presentation/_shared/assets/redhat-logo-white.png">    </p:cNvPr>
+          <p:cNvPr id="6" name="Image 1" descr="/tmp/pcwork/api-patterns-and-practices-grpc/presentation/_shared/assets/redhat-logo-white.png">    </p:cNvPr>
           <p:cNvPicPr>
             <a:picLocks noChangeAspect="1"/>
           </p:cNvPicPr>
@@ -7378,7 +7467,7 @@
       </p:sp>
       <p:pic>
         <p:nvPicPr>
-          <p:cNvPr id="3" name="Image 0" descr="/home/rsedor/Dev/api-patterns-and-practices-grpc/presentation/_shared/assets/logo-candidate-2.png">    </p:cNvPr>
+          <p:cNvPr id="3" name="Image 0" descr="/tmp/pcwork/api-patterns-and-practices-grpc/presentation/_shared/assets/logo-candidate-2.png">    </p:cNvPr>
           <p:cNvPicPr>
             <a:picLocks noChangeAspect="1"/>
           </p:cNvPicPr>
@@ -7480,7 +7569,7 @@
       </p:sp>
       <p:pic>
         <p:nvPicPr>
-          <p:cNvPr id="6" name="Image 1" descr="/home/rsedor/Dev/api-patterns-and-practices-grpc/presentation/_shared/png/07-unary-stub-to-stub.png">    </p:cNvPr>
+          <p:cNvPr id="6" name="Image 1" descr="/tmp/pcwork/api-patterns-and-practices-grpc/presentation/_shared/png/07-unary-stub-to-stub.png">    </p:cNvPr>
           <p:cNvPicPr>
             <a:picLocks noChangeAspect="1"/>
           </p:cNvPicPr>
@@ -7606,7 +7695,7 @@
       </p:sp>
       <p:pic>
         <p:nvPicPr>
-          <p:cNvPr id="3" name="Image 0" descr="/home/rsedor/Dev/api-patterns-and-practices-grpc/presentation/_shared/assets/logo-candidate-2.png">    </p:cNvPr>
+          <p:cNvPr id="3" name="Image 0" descr="/tmp/pcwork/api-patterns-and-practices-grpc/presentation/_shared/assets/logo-candidate-2.png">    </p:cNvPr>
           <p:cNvPicPr>
             <a:picLocks noChangeAspect="1"/>
           </p:cNvPicPr>
@@ -8210,7 +8299,7 @@
       </p:grpSpPr>
       <p:pic>
         <p:nvPicPr>
-          <p:cNvPr id="2" name="Image 0" descr="/home/rsedor/Dev/api-patterns-and-practices-grpc/presentation/_shared/assets/section-panel.png">    </p:cNvPr>
+          <p:cNvPr id="2" name="Image 0" descr="/tmp/pcwork/api-patterns-and-practices-grpc/presentation/_shared/assets/section-panel.png">    </p:cNvPr>
           <p:cNvPicPr>
             <a:picLocks noChangeAspect="1"/>
           </p:cNvPicPr>
@@ -8351,7 +8440,7 @@
       </p:sp>
       <p:pic>
         <p:nvPicPr>
-          <p:cNvPr id="6" name="Image 1" descr="/home/rsedor/Dev/api-patterns-and-practices-grpc/presentation/_shared/assets/redhat-logo-white.png">    </p:cNvPr>
+          <p:cNvPr id="6" name="Image 1" descr="/tmp/pcwork/api-patterns-and-practices-grpc/presentation/_shared/assets/redhat-logo-white.png">    </p:cNvPr>
           <p:cNvPicPr>
             <a:picLocks noChangeAspect="1"/>
           </p:cNvPicPr>
@@ -8439,7 +8528,7 @@
       </p:sp>
       <p:pic>
         <p:nvPicPr>
-          <p:cNvPr id="3" name="Image 0" descr="/home/rsedor/Dev/api-patterns-and-practices-grpc/presentation/_shared/assets/logo-candidate-2.png">    </p:cNvPr>
+          <p:cNvPr id="3" name="Image 0" descr="/tmp/pcwork/api-patterns-and-practices-grpc/presentation/_shared/assets/logo-candidate-2.png">    </p:cNvPr>
           <p:cNvPicPr>
             <a:picLocks noChangeAspect="1"/>
           </p:cNvPicPr>
@@ -8541,7 +8630,7 @@
       </p:sp>
       <p:pic>
         <p:nvPicPr>
-          <p:cNvPr id="6" name="Image 1" descr="/home/rsedor/Dev/api-patterns-and-practices-grpc/presentation/_shared/png/09-client-bidi-streaming.png">    </p:cNvPr>
+          <p:cNvPr id="6" name="Image 1" descr="/tmp/pcwork/api-patterns-and-practices-grpc/presentation/_shared/png/09-client-bidi-streaming.png">    </p:cNvPr>
           <p:cNvPicPr>
             <a:picLocks noChangeAspect="1"/>
           </p:cNvPicPr>
@@ -8667,7 +8756,7 @@
       </p:sp>
       <p:pic>
         <p:nvPicPr>
-          <p:cNvPr id="3" name="Image 0" descr="/home/rsedor/Dev/api-patterns-and-practices-grpc/presentation/_shared/assets/logo-candidate-2.png">    </p:cNvPr>
+          <p:cNvPr id="3" name="Image 0" descr="/tmp/pcwork/api-patterns-and-practices-grpc/presentation/_shared/assets/logo-candidate-2.png">    </p:cNvPr>
           <p:cNvPicPr>
             <a:picLocks noChangeAspect="1"/>
           </p:cNvPicPr>
@@ -9213,7 +9302,7 @@
       </p:sp>
       <p:pic>
         <p:nvPicPr>
-          <p:cNvPr id="3" name="Image 0" descr="/home/rsedor/Dev/api-patterns-and-practices-grpc/presentation/_shared/assets/logo-candidate-2.png">    </p:cNvPr>
+          <p:cNvPr id="3" name="Image 0" descr="/tmp/pcwork/api-patterns-and-practices-grpc/presentation/_shared/assets/logo-candidate-2.png">    </p:cNvPr>
           <p:cNvPicPr>
             <a:picLocks noChangeAspect="1"/>
           </p:cNvPicPr>
@@ -9745,7 +9834,7 @@
       </p:grpSpPr>
       <p:pic>
         <p:nvPicPr>
-          <p:cNvPr id="2" name="Image 0" descr="/home/rsedor/Dev/api-patterns-and-practices-grpc/presentation/_shared/assets/section-panel.png">    </p:cNvPr>
+          <p:cNvPr id="2" name="Image 0" descr="/tmp/pcwork/api-patterns-and-practices-grpc/presentation/_shared/assets/section-panel.png">    </p:cNvPr>
           <p:cNvPicPr>
             <a:picLocks noChangeAspect="1"/>
           </p:cNvPicPr>
@@ -9886,7 +9975,7 @@
       </p:sp>
       <p:pic>
         <p:nvPicPr>
-          <p:cNvPr id="6" name="Image 1" descr="/home/rsedor/Dev/api-patterns-and-practices-grpc/presentation/_shared/assets/redhat-logo-white.png">    </p:cNvPr>
+          <p:cNvPr id="6" name="Image 1" descr="/tmp/pcwork/api-patterns-and-practices-grpc/presentation/_shared/assets/redhat-logo-white.png">    </p:cNvPr>
           <p:cNvPicPr>
             <a:picLocks noChangeAspect="1"/>
           </p:cNvPicPr>
@@ -9974,7 +10063,7 @@
       </p:sp>
       <p:pic>
         <p:nvPicPr>
-          <p:cNvPr id="3" name="Image 0" descr="/home/rsedor/Dev/api-patterns-and-practices-grpc/presentation/_shared/assets/logo-candidate-2.png">    </p:cNvPr>
+          <p:cNvPr id="3" name="Image 0" descr="/tmp/pcwork/api-patterns-and-practices-grpc/presentation/_shared/assets/logo-candidate-2.png">    </p:cNvPr>
           <p:cNvPicPr>
             <a:picLocks noChangeAspect="1"/>
           </p:cNvPicPr>
@@ -10076,7 +10165,7 @@
       </p:sp>
       <p:pic>
         <p:nvPicPr>
-          <p:cNvPr id="6" name="Image 1" descr="/home/rsedor/Dev/api-patterns-and-practices-grpc/presentation/_shared/png/11-rich-error-model.png">    </p:cNvPr>
+          <p:cNvPr id="6" name="Image 1" descr="/tmp/pcwork/api-patterns-and-practices-grpc/presentation/_shared/png/11-rich-error-model.png">    </p:cNvPr>
           <p:cNvPicPr>
             <a:picLocks noChangeAspect="1"/>
           </p:cNvPicPr>
@@ -10202,7 +10291,7 @@
       </p:sp>
       <p:pic>
         <p:nvPicPr>
-          <p:cNvPr id="3" name="Image 0" descr="/home/rsedor/Dev/api-patterns-and-practices-grpc/presentation/_shared/assets/logo-candidate-2.png">    </p:cNvPr>
+          <p:cNvPr id="3" name="Image 0" descr="/tmp/pcwork/api-patterns-and-practices-grpc/presentation/_shared/assets/logo-candidate-2.png">    </p:cNvPr>
           <p:cNvPicPr>
             <a:picLocks noChangeAspect="1"/>
           </p:cNvPicPr>
@@ -10712,7 +10801,7 @@
       </p:sp>
       <p:pic>
         <p:nvPicPr>
-          <p:cNvPr id="3" name="Image 0" descr="/home/rsedor/Dev/api-patterns-and-practices-grpc/presentation/_shared/assets/logo-candidate-2.png">    </p:cNvPr>
+          <p:cNvPr id="3" name="Image 0" descr="/tmp/pcwork/api-patterns-and-practices-grpc/presentation/_shared/assets/logo-candidate-2.png">    </p:cNvPr>
           <p:cNvPicPr>
             <a:picLocks noChangeAspect="1"/>
           </p:cNvPicPr>
@@ -11210,7 +11299,7 @@
       </p:sp>
       <p:pic>
         <p:nvPicPr>
-          <p:cNvPr id="3" name="Image 0" descr="/home/rsedor/Dev/api-patterns-and-practices-grpc/presentation/_shared/assets/logo-candidate-2.png">    </p:cNvPr>
+          <p:cNvPr id="3" name="Image 0" descr="/tmp/pcwork/api-patterns-and-practices-grpc/presentation/_shared/assets/logo-candidate-2.png">    </p:cNvPr>
           <p:cNvPicPr>
             <a:picLocks noChangeAspect="1"/>
           </p:cNvPicPr>
@@ -11724,7 +11813,7 @@
       </p:grpSpPr>
       <p:pic>
         <p:nvPicPr>
-          <p:cNvPr id="2" name="Image 0" descr="/home/rsedor/Dev/api-patterns-and-practices-grpc/presentation/_shared/assets/section-panel.png">    </p:cNvPr>
+          <p:cNvPr id="2" name="Image 0" descr="/tmp/pcwork/api-patterns-and-practices-grpc/presentation/_shared/assets/section-panel.png">    </p:cNvPr>
           <p:cNvPicPr>
             <a:picLocks noChangeAspect="1"/>
           </p:cNvPicPr>
@@ -11865,7 +11954,7 @@
       </p:sp>
       <p:pic>
         <p:nvPicPr>
-          <p:cNvPr id="6" name="Image 1" descr="/home/rsedor/Dev/api-patterns-and-practices-grpc/presentation/_shared/assets/redhat-logo-white.png">    </p:cNvPr>
+          <p:cNvPr id="6" name="Image 1" descr="/tmp/pcwork/api-patterns-and-practices-grpc/presentation/_shared/assets/redhat-logo-white.png">    </p:cNvPr>
           <p:cNvPicPr>
             <a:picLocks noChangeAspect="1"/>
           </p:cNvPicPr>
@@ -11953,7 +12042,7 @@
       </p:sp>
       <p:pic>
         <p:nvPicPr>
-          <p:cNvPr id="3" name="Image 0" descr="/home/rsedor/Dev/api-patterns-and-practices-grpc/presentation/_shared/assets/logo-candidate-2.png">    </p:cNvPr>
+          <p:cNvPr id="3" name="Image 0" descr="/tmp/pcwork/api-patterns-and-practices-grpc/presentation/_shared/assets/logo-candidate-2.png">    </p:cNvPr>
           <p:cNvPicPr>
             <a:picLocks noChangeAspect="1"/>
           </p:cNvPicPr>
@@ -12055,7 +12144,7 @@
       </p:sp>
       <p:pic>
         <p:nvPicPr>
-          <p:cNvPr id="6" name="Image 1" descr="/home/rsedor/Dev/api-patterns-and-practices-grpc/presentation/_shared/png/13-fieldmask-projection.png">    </p:cNvPr>
+          <p:cNvPr id="6" name="Image 1" descr="/tmp/pcwork/api-patterns-and-practices-grpc/presentation/_shared/png/13-fieldmask-projection.png">    </p:cNvPr>
           <p:cNvPicPr>
             <a:picLocks noChangeAspect="1"/>
           </p:cNvPicPr>
@@ -12181,7 +12270,7 @@
       </p:sp>
       <p:pic>
         <p:nvPicPr>
-          <p:cNvPr id="3" name="Image 0" descr="/home/rsedor/Dev/api-patterns-and-practices-grpc/presentation/_shared/assets/logo-candidate-2.png">    </p:cNvPr>
+          <p:cNvPr id="3" name="Image 0" descr="/tmp/pcwork/api-patterns-and-practices-grpc/presentation/_shared/assets/logo-candidate-2.png">    </p:cNvPr>
           <p:cNvPicPr>
             <a:picLocks noChangeAspect="1"/>
           </p:cNvPicPr>
@@ -12799,7 +12888,7 @@
       </p:sp>
       <p:pic>
         <p:nvPicPr>
-          <p:cNvPr id="3" name="Image 0" descr="/home/rsedor/Dev/api-patterns-and-practices-grpc/presentation/_shared/assets/logo-candidate-2.png">    </p:cNvPr>
+          <p:cNvPr id="3" name="Image 0" descr="/tmp/pcwork/api-patterns-and-practices-grpc/presentation/_shared/assets/logo-candidate-2.png">    </p:cNvPr>
           <p:cNvPicPr>
             <a:picLocks noChangeAspect="1"/>
           </p:cNvPicPr>
@@ -12901,7 +12990,7 @@
       </p:sp>
       <p:pic>
         <p:nvPicPr>
-          <p:cNvPr id="6" name="Image 1" descr="/home/rsedor/Dev/api-patterns-and-practices-grpc/presentation/_shared/png/14-buf-breaking-gate.png">    </p:cNvPr>
+          <p:cNvPr id="6" name="Image 1" descr="/tmp/pcwork/api-patterns-and-practices-grpc/presentation/_shared/png/14-buf-breaking-gate.png">    </p:cNvPr>
           <p:cNvPicPr>
             <a:picLocks noChangeAspect="1"/>
           </p:cNvPicPr>
@@ -12995,7 +13084,7 @@
       </p:grpSpPr>
       <p:pic>
         <p:nvPicPr>
-          <p:cNvPr id="2" name="Image 0" descr="/home/rsedor/Dev/api-patterns-and-practices-grpc/presentation/_shared/assets/section-panel.png">    </p:cNvPr>
+          <p:cNvPr id="2" name="Image 0" descr="/tmp/pcwork/api-patterns-and-practices-grpc/presentation/_shared/assets/section-panel.png">    </p:cNvPr>
           <p:cNvPicPr>
             <a:picLocks noChangeAspect="1"/>
           </p:cNvPicPr>
@@ -13136,7 +13225,7 @@
       </p:sp>
       <p:pic>
         <p:nvPicPr>
-          <p:cNvPr id="6" name="Image 1" descr="/home/rsedor/Dev/api-patterns-and-practices-grpc/presentation/_shared/assets/redhat-logo-white.png">    </p:cNvPr>
+          <p:cNvPr id="6" name="Image 1" descr="/tmp/pcwork/api-patterns-and-practices-grpc/presentation/_shared/assets/redhat-logo-white.png">    </p:cNvPr>
           <p:cNvPicPr>
             <a:picLocks noChangeAspect="1"/>
           </p:cNvPicPr>
@@ -13224,7 +13313,7 @@
       </p:sp>
       <p:pic>
         <p:nvPicPr>
-          <p:cNvPr id="3" name="Image 0" descr="/home/rsedor/Dev/api-patterns-and-practices-grpc/presentation/_shared/assets/logo-candidate-2.png">    </p:cNvPr>
+          <p:cNvPr id="3" name="Image 0" descr="/tmp/pcwork/api-patterns-and-practices-grpc/presentation/_shared/assets/logo-candidate-2.png">    </p:cNvPr>
           <p:cNvPicPr>
             <a:picLocks noChangeAspect="1"/>
           </p:cNvPicPr>
@@ -13326,7 +13415,7 @@
       </p:sp>
       <p:pic>
         <p:nvPicPr>
-          <p:cNvPr id="6" name="Image 1" descr="/home/rsedor/Dev/api-patterns-and-practices-grpc/presentation/_shared/png/15-python-gil-concurrency.png">    </p:cNvPr>
+          <p:cNvPr id="6" name="Image 1" descr="/tmp/pcwork/api-patterns-and-practices-grpc/presentation/_shared/png/15-python-gil-concurrency.png">    </p:cNvPr>
           <p:cNvPicPr>
             <a:picLocks noChangeAspect="1"/>
           </p:cNvPicPr>
@@ -13452,7 +13541,7 @@
       </p:sp>
       <p:pic>
         <p:nvPicPr>
-          <p:cNvPr id="3" name="Image 0" descr="/home/rsedor/Dev/api-patterns-and-practices-grpc/presentation/_shared/assets/logo-candidate-2.png">    </p:cNvPr>
+          <p:cNvPr id="3" name="Image 0" descr="/tmp/pcwork/api-patterns-and-practices-grpc/presentation/_shared/assets/logo-candidate-2.png">    </p:cNvPr>
           <p:cNvPicPr>
             <a:picLocks noChangeAspect="1"/>
           </p:cNvPicPr>
@@ -13554,7 +13643,7 @@
       </p:sp>
       <p:pic>
         <p:nvPicPr>
-          <p:cNvPr id="6" name="Image 1" descr="/home/rsedor/Dev/api-patterns-and-practices-grpc/presentation/_shared/png/15-thread-exhaustion-overlap.png">    </p:cNvPr>
+          <p:cNvPr id="6" name="Image 1" descr="/tmp/pcwork/api-patterns-and-practices-grpc/presentation/_shared/png/15-thread-exhaustion-overlap.png">    </p:cNvPr>
           <p:cNvPicPr>
             <a:picLocks noChangeAspect="1"/>
           </p:cNvPicPr>
@@ -13680,7 +13769,7 @@
       </p:sp>
       <p:pic>
         <p:nvPicPr>
-          <p:cNvPr id="3" name="Image 0" descr="/home/rsedor/Dev/api-patterns-and-practices-grpc/presentation/_shared/assets/logo-candidate-2.png">    </p:cNvPr>
+          <p:cNvPr id="3" name="Image 0" descr="/tmp/pcwork/api-patterns-and-practices-grpc/presentation/_shared/assets/logo-candidate-2.png">    </p:cNvPr>
           <p:cNvPicPr>
             <a:picLocks noChangeAspect="1"/>
           </p:cNvPicPr>
@@ -14248,7 +14337,7 @@
       </p:grpSpPr>
       <p:pic>
         <p:nvPicPr>
-          <p:cNvPr id="2" name="Image 0" descr="/home/rsedor/Dev/api-patterns-and-practices-grpc/presentation/_shared/assets/section-panel.png">    </p:cNvPr>
+          <p:cNvPr id="2" name="Image 0" descr="/tmp/pcwork/api-patterns-and-practices-grpc/presentation/_shared/assets/section-panel.png">    </p:cNvPr>
           <p:cNvPicPr>
             <a:picLocks noChangeAspect="1"/>
           </p:cNvPicPr>
@@ -14389,7 +14478,7 @@
       </p:sp>
       <p:pic>
         <p:nvPicPr>
-          <p:cNvPr id="6" name="Image 1" descr="/home/rsedor/Dev/api-patterns-and-practices-grpc/presentation/_shared/assets/redhat-logo-white.png">    </p:cNvPr>
+          <p:cNvPr id="6" name="Image 1" descr="/tmp/pcwork/api-patterns-and-practices-grpc/presentation/_shared/assets/redhat-logo-white.png">    </p:cNvPr>
           <p:cNvPicPr>
             <a:picLocks noChangeAspect="1"/>
           </p:cNvPicPr>
@@ -14477,7 +14566,7 @@
       </p:sp>
       <p:pic>
         <p:nvPicPr>
-          <p:cNvPr id="3" name="Image 0" descr="/home/rsedor/Dev/api-patterns-and-practices-grpc/presentation/_shared/assets/logo-candidate-2.png">    </p:cNvPr>
+          <p:cNvPr id="3" name="Image 0" descr="/tmp/pcwork/api-patterns-and-practices-grpc/presentation/_shared/assets/logo-candidate-2.png">    </p:cNvPr>
           <p:cNvPicPr>
             <a:picLocks noChangeAspect="1"/>
           </p:cNvPicPr>
@@ -14800,7 +14889,7 @@
       </p:sp>
       <p:pic>
         <p:nvPicPr>
-          <p:cNvPr id="3" name="Image 0" descr="/home/rsedor/Dev/api-patterns-and-practices-grpc/presentation/_shared/assets/logo-candidate-2.png">    </p:cNvPr>
+          <p:cNvPr id="3" name="Image 0" descr="/tmp/pcwork/api-patterns-and-practices-grpc/presentation/_shared/assets/logo-candidate-2.png">    </p:cNvPr>
           <p:cNvPicPr>
             <a:picLocks noChangeAspect="1"/>
           </p:cNvPicPr>
@@ -14902,7 +14991,7 @@
       </p:sp>
       <p:pic>
         <p:nvPicPr>
-          <p:cNvPr id="6" name="Image 1" descr="/home/rsedor/Dev/api-patterns-and-practices-grpc/presentation/_shared/png/16-operation-lifecycle.png">    </p:cNvPr>
+          <p:cNvPr id="6" name="Image 1" descr="/tmp/pcwork/api-patterns-and-practices-grpc/presentation/_shared/png/16-operation-lifecycle.png">    </p:cNvPr>
           <p:cNvPicPr>
             <a:picLocks noChangeAspect="1"/>
           </p:cNvPicPr>
@@ -15028,7 +15117,7 @@
       </p:sp>
       <p:pic>
         <p:nvPicPr>
-          <p:cNvPr id="3" name="Image 0" descr="/home/rsedor/Dev/api-patterns-and-practices-grpc/presentation/_shared/assets/logo-candidate-2.png">    </p:cNvPr>
+          <p:cNvPr id="3" name="Image 0" descr="/tmp/pcwork/api-patterns-and-practices-grpc/presentation/_shared/assets/logo-candidate-2.png">    </p:cNvPr>
           <p:cNvPicPr>
             <a:picLocks noChangeAspect="1"/>
           </p:cNvPicPr>
@@ -15704,7 +15793,7 @@
       </p:grpSpPr>
       <p:pic>
         <p:nvPicPr>
-          <p:cNvPr id="2" name="Image 0" descr="/home/rsedor/Dev/api-patterns-and-practices-grpc/presentation/_shared/assets/section-panel.png">    </p:cNvPr>
+          <p:cNvPr id="2" name="Image 0" descr="/tmp/pcwork/api-patterns-and-practices-grpc/presentation/_shared/assets/section-panel.png">    </p:cNvPr>
           <p:cNvPicPr>
             <a:picLocks noChangeAspect="1"/>
           </p:cNvPicPr>
@@ -15845,7 +15934,7 @@
       </p:sp>
       <p:pic>
         <p:nvPicPr>
-          <p:cNvPr id="6" name="Image 1" descr="/home/rsedor/Dev/api-patterns-and-practices-grpc/presentation/_shared/assets/redhat-logo-white.png">    </p:cNvPr>
+          <p:cNvPr id="6" name="Image 1" descr="/tmp/pcwork/api-patterns-and-practices-grpc/presentation/_shared/assets/redhat-logo-white.png">    </p:cNvPr>
           <p:cNvPicPr>
             <a:picLocks noChangeAspect="1"/>
           </p:cNvPicPr>
@@ -15933,7 +16022,7 @@
       </p:sp>
       <p:pic>
         <p:nvPicPr>
-          <p:cNvPr id="3" name="Image 0" descr="/home/rsedor/Dev/api-patterns-and-practices-grpc/presentation/_shared/assets/logo-candidate-2.png">    </p:cNvPr>
+          <p:cNvPr id="3" name="Image 0" descr="/tmp/pcwork/api-patterns-and-practices-grpc/presentation/_shared/assets/logo-candidate-2.png">    </p:cNvPr>
           <p:cNvPicPr>
             <a:picLocks noChangeAspect="1"/>
           </p:cNvPicPr>
@@ -16035,7 +16124,7 @@
       </p:sp>
       <p:pic>
         <p:nvPicPr>
-          <p:cNvPr id="6" name="Image 1" descr="/home/rsedor/Dev/api-patterns-and-practices-grpc/presentation/_shared/png/17-slow-consumer-backpressure.png">    </p:cNvPr>
+          <p:cNvPr id="6" name="Image 1" descr="/tmp/pcwork/api-patterns-and-practices-grpc/presentation/_shared/png/17-slow-consumer-backpressure.png">    </p:cNvPr>
           <p:cNvPicPr>
             <a:picLocks noChangeAspect="1"/>
           </p:cNvPicPr>
@@ -16161,7 +16250,7 @@
       </p:sp>
       <p:pic>
         <p:nvPicPr>
-          <p:cNvPr id="3" name="Image 0" descr="/home/rsedor/Dev/api-patterns-and-practices-grpc/presentation/_shared/assets/logo-candidate-2.png">    </p:cNvPr>
+          <p:cNvPr id="3" name="Image 0" descr="/tmp/pcwork/api-patterns-and-practices-grpc/presentation/_shared/assets/logo-candidate-2.png">    </p:cNvPr>
           <p:cNvPicPr>
             <a:picLocks noChangeAspect="1"/>
           </p:cNvPicPr>
@@ -16853,7 +16942,7 @@
       </p:grpSpPr>
       <p:pic>
         <p:nvPicPr>
-          <p:cNvPr id="2" name="Image 0" descr="/home/rsedor/Dev/api-patterns-and-practices-grpc/presentation/_shared/assets/section-panel.png">    </p:cNvPr>
+          <p:cNvPr id="2" name="Image 0" descr="/tmp/pcwork/api-patterns-and-practices-grpc/presentation/_shared/assets/section-panel.png">    </p:cNvPr>
           <p:cNvPicPr>
             <a:picLocks noChangeAspect="1"/>
           </p:cNvPicPr>
@@ -16994,7 +17083,7 @@
       </p:sp>
       <p:pic>
         <p:nvPicPr>
-          <p:cNvPr id="6" name="Image 1" descr="/home/rsedor/Dev/api-patterns-and-practices-grpc/presentation/_shared/assets/redhat-logo-white.png">    </p:cNvPr>
+          <p:cNvPr id="6" name="Image 1" descr="/tmp/pcwork/api-patterns-and-practices-grpc/presentation/_shared/assets/redhat-logo-white.png">    </p:cNvPr>
           <p:cNvPicPr>
             <a:picLocks noChangeAspect="1"/>
           </p:cNvPicPr>
@@ -17082,7 +17171,7 @@
       </p:sp>
       <p:pic>
         <p:nvPicPr>
-          <p:cNvPr id="3" name="Image 0" descr="/home/rsedor/Dev/api-patterns-and-practices-grpc/presentation/_shared/assets/logo-candidate-2.png">    </p:cNvPr>
+          <p:cNvPr id="3" name="Image 0" descr="/tmp/pcwork/api-patterns-and-practices-grpc/presentation/_shared/assets/logo-candidate-2.png">    </p:cNvPr>
           <p:cNvPicPr>
             <a:picLocks noChangeAspect="1"/>
           </p:cNvPicPr>
@@ -17184,7 +17273,7 @@
       </p:sp>
       <p:pic>
         <p:nvPicPr>
-          <p:cNvPr id="6" name="Image 1" descr="/home/rsedor/Dev/api-patterns-and-practices-grpc/presentation/_shared/png/19-mtls-mutual-verification.png">    </p:cNvPr>
+          <p:cNvPr id="6" name="Image 1" descr="/tmp/pcwork/api-patterns-and-practices-grpc/presentation/_shared/png/19-mtls-mutual-verification.png">    </p:cNvPr>
           <p:cNvPicPr>
             <a:picLocks noChangeAspect="1"/>
           </p:cNvPicPr>
@@ -17310,7 +17399,7 @@
       </p:sp>
       <p:pic>
         <p:nvPicPr>
-          <p:cNvPr id="3" name="Image 0" descr="/home/rsedor/Dev/api-patterns-and-practices-grpc/presentation/_shared/assets/logo-candidate-2.png">    </p:cNvPr>
+          <p:cNvPr id="3" name="Image 0" descr="/tmp/pcwork/api-patterns-and-practices-grpc/presentation/_shared/assets/logo-candidate-2.png">    </p:cNvPr>
           <p:cNvPicPr>
             <a:picLocks noChangeAspect="1"/>
           </p:cNvPicPr>
@@ -17860,7 +17949,7 @@
       </p:grpSpPr>
       <p:pic>
         <p:nvPicPr>
-          <p:cNvPr id="2" name="Image 0" descr="/home/rsedor/Dev/api-patterns-and-practices-grpc/presentation/_shared/assets/section-panel.png">    </p:cNvPr>
+          <p:cNvPr id="2" name="Image 0" descr="/tmp/pcwork/api-patterns-and-practices-grpc/presentation/_shared/assets/section-panel.png">    </p:cNvPr>
           <p:cNvPicPr>
             <a:picLocks noChangeAspect="1"/>
           </p:cNvPicPr>
@@ -18001,7 +18090,7 @@
       </p:sp>
       <p:pic>
         <p:nvPicPr>
-          <p:cNvPr id="6" name="Image 1" descr="/home/rsedor/Dev/api-patterns-and-practices-grpc/presentation/_shared/assets/redhat-logo-white.png">    </p:cNvPr>
+          <p:cNvPr id="6" name="Image 1" descr="/tmp/pcwork/api-patterns-and-practices-grpc/presentation/_shared/assets/redhat-logo-white.png">    </p:cNvPr>
           <p:cNvPicPr>
             <a:picLocks noChangeAspect="1"/>
           </p:cNvPicPr>
@@ -18089,7 +18178,7 @@
       </p:sp>
       <p:pic>
         <p:nvPicPr>
-          <p:cNvPr id="3" name="Image 0" descr="/home/rsedor/Dev/api-patterns-and-practices-grpc/presentation/_shared/assets/logo-candidate-2.png">    </p:cNvPr>
+          <p:cNvPr id="3" name="Image 0" descr="/tmp/pcwork/api-patterns-and-practices-grpc/presentation/_shared/assets/logo-candidate-2.png">    </p:cNvPr>
           <p:cNvPicPr>
             <a:picLocks noChangeAspect="1"/>
           </p:cNvPicPr>
@@ -18191,7 +18280,7 @@
       </p:sp>
       <p:pic>
         <p:nvPicPr>
-          <p:cNvPr id="6" name="Image 1" descr="/home/rsedor/Dev/api-patterns-and-practices-grpc/presentation/_shared/png/20-jwt-in-metadata-flow.png">    </p:cNvPr>
+          <p:cNvPr id="6" name="Image 1" descr="/tmp/pcwork/api-patterns-and-practices-grpc/presentation/_shared/png/20-jwt-in-metadata-flow.png">    </p:cNvPr>
           <p:cNvPicPr>
             <a:picLocks noChangeAspect="1"/>
           </p:cNvPicPr>
@@ -18285,7 +18374,7 @@
       </p:grpSpPr>
       <p:pic>
         <p:nvPicPr>
-          <p:cNvPr id="2" name="Image 0" descr="/home/rsedor/Dev/api-patterns-and-practices-grpc/presentation/_shared/assets/section-panel.png">    </p:cNvPr>
+          <p:cNvPr id="2" name="Image 0" descr="/tmp/pcwork/api-patterns-and-practices-grpc/presentation/_shared/assets/section-panel.png">    </p:cNvPr>
           <p:cNvPicPr>
             <a:picLocks noChangeAspect="1"/>
           </p:cNvPicPr>
@@ -18426,7 +18515,7 @@
       </p:sp>
       <p:pic>
         <p:nvPicPr>
-          <p:cNvPr id="6" name="Image 1" descr="/home/rsedor/Dev/api-patterns-and-practices-grpc/presentation/_shared/assets/redhat-logo-white.png">    </p:cNvPr>
+          <p:cNvPr id="6" name="Image 1" descr="/tmp/pcwork/api-patterns-and-practices-grpc/presentation/_shared/assets/redhat-logo-white.png">    </p:cNvPr>
           <p:cNvPicPr>
             <a:picLocks noChangeAspect="1"/>
           </p:cNvPicPr>
@@ -18514,7 +18603,7 @@
       </p:sp>
       <p:pic>
         <p:nvPicPr>
-          <p:cNvPr id="3" name="Image 0" descr="/home/rsedor/Dev/api-patterns-and-practices-grpc/presentation/_shared/assets/logo-candidate-2.png">    </p:cNvPr>
+          <p:cNvPr id="3" name="Image 0" descr="/tmp/pcwork/api-patterns-and-practices-grpc/presentation/_shared/assets/logo-candidate-2.png">    </p:cNvPr>
           <p:cNvPicPr>
             <a:picLocks noChangeAspect="1"/>
           </p:cNvPicPr>
@@ -19208,7 +19297,7 @@
       </p:grpSpPr>
       <p:pic>
         <p:nvPicPr>
-          <p:cNvPr id="2" name="Image 0" descr="/home/rsedor/Dev/api-patterns-and-practices-grpc/presentation/_shared/assets/section-panel.png">    </p:cNvPr>
+          <p:cNvPr id="2" name="Image 0" descr="/tmp/pcwork/api-patterns-and-practices-grpc/presentation/_shared/assets/section-panel.png">    </p:cNvPr>
           <p:cNvPicPr>
             <a:picLocks noChangeAspect="1"/>
           </p:cNvPicPr>
@@ -19349,7 +19438,7 @@
       </p:sp>
       <p:pic>
         <p:nvPicPr>
-          <p:cNvPr id="6" name="Image 1" descr="/home/rsedor/Dev/api-patterns-and-practices-grpc/presentation/_shared/assets/redhat-logo-white.png">    </p:cNvPr>
+          <p:cNvPr id="6" name="Image 1" descr="/tmp/pcwork/api-patterns-and-practices-grpc/presentation/_shared/assets/redhat-logo-white.png">    </p:cNvPr>
           <p:cNvPicPr>
             <a:picLocks noChangeAspect="1"/>
           </p:cNvPicPr>
@@ -19437,7 +19526,7 @@
       </p:sp>
       <p:pic>
         <p:nvPicPr>
-          <p:cNvPr id="3" name="Image 0" descr="/home/rsedor/Dev/api-patterns-and-practices-grpc/presentation/_shared/assets/logo-candidate-2.png">    </p:cNvPr>
+          <p:cNvPr id="3" name="Image 0" descr="/tmp/pcwork/api-patterns-and-practices-grpc/presentation/_shared/assets/logo-candidate-2.png">    </p:cNvPr>
           <p:cNvPicPr>
             <a:picLocks noChangeAspect="1"/>
           </p:cNvPicPr>
@@ -19539,7 +19628,7 @@
       </p:sp>
       <p:pic>
         <p:nvPicPr>
-          <p:cNvPr id="6" name="Image 1" descr="/home/rsedor/Dev/api-patterns-and-practices-grpc/presentation/_shared/png/21-observability-surfaces.png">    </p:cNvPr>
+          <p:cNvPr id="6" name="Image 1" descr="/tmp/pcwork/api-patterns-and-practices-grpc/presentation/_shared/png/21-observability-surfaces.png">    </p:cNvPr>
           <p:cNvPicPr>
             <a:picLocks noChangeAspect="1"/>
           </p:cNvPicPr>
@@ -19665,7 +19754,7 @@
       </p:sp>
       <p:pic>
         <p:nvPicPr>
-          <p:cNvPr id="3" name="Image 0" descr="/home/rsedor/Dev/api-patterns-and-practices-grpc/presentation/_shared/assets/logo-candidate-2.png">    </p:cNvPr>
+          <p:cNvPr id="3" name="Image 0" descr="/tmp/pcwork/api-patterns-and-practices-grpc/presentation/_shared/assets/logo-candidate-2.png">    </p:cNvPr>
           <p:cNvPicPr>
             <a:picLocks noChangeAspect="1"/>
           </p:cNvPicPr>
@@ -20359,7 +20448,7 @@
       </p:grpSpPr>
       <p:pic>
         <p:nvPicPr>
-          <p:cNvPr id="2" name="Image 0" descr="/home/rsedor/Dev/api-patterns-and-practices-grpc/presentation/_shared/assets/section-panel.png">    </p:cNvPr>
+          <p:cNvPr id="2" name="Image 0" descr="/tmp/pcwork/api-patterns-and-practices-grpc/presentation/_shared/assets/section-panel.png">    </p:cNvPr>
           <p:cNvPicPr>
             <a:picLocks noChangeAspect="1"/>
           </p:cNvPicPr>
@@ -20500,7 +20589,7 @@
       </p:sp>
       <p:pic>
         <p:nvPicPr>
-          <p:cNvPr id="6" name="Image 1" descr="/home/rsedor/Dev/api-patterns-and-practices-grpc/presentation/_shared/assets/redhat-logo-white.png">    </p:cNvPr>
+          <p:cNvPr id="6" name="Image 1" descr="/tmp/pcwork/api-patterns-and-practices-grpc/presentation/_shared/assets/redhat-logo-white.png">    </p:cNvPr>
           <p:cNvPicPr>
             <a:picLocks noChangeAspect="1"/>
           </p:cNvPicPr>
@@ -20588,7 +20677,7 @@
       </p:sp>
       <p:pic>
         <p:nvPicPr>
-          <p:cNvPr id="3" name="Image 0" descr="/home/rsedor/Dev/api-patterns-and-practices-grpc/presentation/_shared/assets/logo-candidate-2.png">    </p:cNvPr>
+          <p:cNvPr id="3" name="Image 0" descr="/tmp/pcwork/api-patterns-and-practices-grpc/presentation/_shared/assets/logo-candidate-2.png">    </p:cNvPr>
           <p:cNvPicPr>
             <a:picLocks noChangeAspect="1"/>
           </p:cNvPicPr>
@@ -20690,7 +20779,7 @@
       </p:sp>
       <p:pic>
         <p:nvPicPr>
-          <p:cNvPr id="6" name="Image 1" descr="/home/rsedor/Dev/api-patterns-and-practices-grpc/presentation/_shared/png/22-grpc-lb-problem.png">    </p:cNvPr>
+          <p:cNvPr id="6" name="Image 1" descr="/tmp/pcwork/api-patterns-and-practices-grpc/presentation/_shared/png/22-grpc-lb-problem.png">    </p:cNvPr>
           <p:cNvPicPr>
             <a:picLocks noChangeAspect="1"/>
           </p:cNvPicPr>
@@ -20816,7 +20905,7 @@
       </p:sp>
       <p:pic>
         <p:nvPicPr>
-          <p:cNvPr id="3" name="Image 0" descr="/home/rsedor/Dev/api-patterns-and-practices-grpc/presentation/_shared/assets/logo-candidate-2.png">    </p:cNvPr>
+          <p:cNvPr id="3" name="Image 0" descr="/tmp/pcwork/api-patterns-and-practices-grpc/presentation/_shared/assets/logo-candidate-2.png">    </p:cNvPr>
           <p:cNvPicPr>
             <a:picLocks noChangeAspect="1"/>
           </p:cNvPicPr>
@@ -21416,7 +21505,7 @@
       </p:sp>
       <p:pic>
         <p:nvPicPr>
-          <p:cNvPr id="3" name="Image 0" descr="/home/rsedor/Dev/api-patterns-and-practices-grpc/presentation/_shared/assets/logo-candidate-2.png">    </p:cNvPr>
+          <p:cNvPr id="3" name="Image 0" descr="/tmp/pcwork/api-patterns-and-practices-grpc/presentation/_shared/assets/logo-candidate-2.png">    </p:cNvPr>
           <p:cNvPicPr>
             <a:picLocks noChangeAspect="1"/>
           </p:cNvPicPr>
@@ -21518,7 +21607,7 @@
       </p:sp>
       <p:pic>
         <p:nvPicPr>
-          <p:cNvPr id="6" name="Image 1" descr="/home/rsedor/Dev/api-patterns-and-practices-grpc/presentation/_shared/png/23-grpc-web-framing.png">    </p:cNvPr>
+          <p:cNvPr id="6" name="Image 1" descr="/tmp/pcwork/api-patterns-and-practices-grpc/presentation/_shared/png/23-grpc-web-framing.png">    </p:cNvPr>
           <p:cNvPicPr>
             <a:picLocks noChangeAspect="1"/>
           </p:cNvPicPr>
@@ -21644,7 +21733,7 @@
       </p:sp>
       <p:pic>
         <p:nvPicPr>
-          <p:cNvPr id="3" name="Image 0" descr="/home/rsedor/Dev/api-patterns-and-practices-grpc/presentation/_shared/assets/logo-candidate-2.png">    </p:cNvPr>
+          <p:cNvPr id="3" name="Image 0" descr="/tmp/pcwork/api-patterns-and-practices-grpc/presentation/_shared/assets/logo-candidate-2.png">    </p:cNvPr>
           <p:cNvPicPr>
             <a:picLocks noChangeAspect="1"/>
           </p:cNvPicPr>
@@ -22248,7 +22337,7 @@
       </p:grpSpPr>
       <p:pic>
         <p:nvPicPr>
-          <p:cNvPr id="2" name="Image 0" descr="/home/rsedor/Dev/api-patterns-and-practices-grpc/presentation/_shared/assets/section-panel.png">    </p:cNvPr>
+          <p:cNvPr id="2" name="Image 0" descr="/tmp/pcwork/api-patterns-and-practices-grpc/presentation/_shared/assets/section-panel.png">    </p:cNvPr>
           <p:cNvPicPr>
             <a:picLocks noChangeAspect="1"/>
           </p:cNvPicPr>
@@ -22389,7 +22478,7 @@
       </p:sp>
       <p:pic>
         <p:nvPicPr>
-          <p:cNvPr id="6" name="Image 1" descr="/home/rsedor/Dev/api-patterns-and-practices-grpc/presentation/_shared/assets/redhat-logo-white.png">    </p:cNvPr>
+          <p:cNvPr id="6" name="Image 1" descr="/tmp/pcwork/api-patterns-and-practices-grpc/presentation/_shared/assets/redhat-logo-white.png">    </p:cNvPr>
           <p:cNvPicPr>
             <a:picLocks noChangeAspect="1"/>
           </p:cNvPicPr>
@@ -22477,7 +22566,7 @@
       </p:sp>
       <p:pic>
         <p:nvPicPr>
-          <p:cNvPr id="3" name="Image 0" descr="/home/rsedor/Dev/api-patterns-and-practices-grpc/presentation/_shared/assets/logo-candidate-2.png">    </p:cNvPr>
+          <p:cNvPr id="3" name="Image 0" descr="/tmp/pcwork/api-patterns-and-practices-grpc/presentation/_shared/assets/logo-candidate-2.png">    </p:cNvPr>
           <p:cNvPicPr>
             <a:picLocks noChangeAspect="1"/>
           </p:cNvPicPr>
@@ -23095,7 +23184,7 @@
       </p:sp>
       <p:pic>
         <p:nvPicPr>
-          <p:cNvPr id="3" name="Image 0" descr="/home/rsedor/Dev/api-patterns-and-practices-grpc/presentation/_shared/assets/logo-candidate-2.png">    </p:cNvPr>
+          <p:cNvPr id="3" name="Image 0" descr="/tmp/pcwork/api-patterns-and-practices-grpc/presentation/_shared/assets/logo-candidate-2.png">    </p:cNvPr>
           <p:cNvPicPr>
             <a:picLocks noChangeAspect="1"/>
           </p:cNvPicPr>
@@ -23197,7 +23286,7 @@
       </p:sp>
       <p:pic>
         <p:nvPicPr>
-          <p:cNvPr id="6" name="Image 1" descr="/home/rsedor/Dev/api-patterns-and-practices-grpc/presentation/_shared/png/25-grpc-test-pyramid.png">    </p:cNvPr>
+          <p:cNvPr id="6" name="Image 1" descr="/tmp/pcwork/api-patterns-and-practices-grpc/presentation/_shared/png/25-grpc-test-pyramid.png">    </p:cNvPr>
           <p:cNvPicPr>
             <a:picLocks noChangeAspect="1"/>
           </p:cNvPicPr>
@@ -23323,7 +23412,7 @@
       </p:sp>
       <p:pic>
         <p:nvPicPr>
-          <p:cNvPr id="3" name="Image 0" descr="/home/rsedor/Dev/api-patterns-and-practices-grpc/presentation/_shared/assets/logo-candidate-2.png">    </p:cNvPr>
+          <p:cNvPr id="3" name="Image 0" descr="/tmp/pcwork/api-patterns-and-practices-grpc/presentation/_shared/assets/logo-candidate-2.png">    </p:cNvPr>
           <p:cNvPicPr>
             <a:picLocks noChangeAspect="1"/>
           </p:cNvPicPr>
@@ -23995,7 +24084,7 @@
       </p:sp>
       <p:pic>
         <p:nvPicPr>
-          <p:cNvPr id="3" name="Image 0" descr="/home/rsedor/Dev/api-patterns-and-practices-grpc/presentation/_shared/assets/logo-candidate-2.png">    </p:cNvPr>
+          <p:cNvPr id="3" name="Image 0" descr="/tmp/pcwork/api-patterns-and-practices-grpc/presentation/_shared/assets/logo-candidate-2.png">    </p:cNvPr>
           <p:cNvPicPr>
             <a:picLocks noChangeAspect="1"/>
           </p:cNvPicPr>
@@ -24545,7 +24634,7 @@
       </p:grpSpPr>
       <p:pic>
         <p:nvPicPr>
-          <p:cNvPr id="2" name="Image 0" descr="/home/rsedor/Dev/api-patterns-and-practices-grpc/presentation/_shared/assets/section-panel.png">    </p:cNvPr>
+          <p:cNvPr id="2" name="Image 0" descr="/tmp/pcwork/api-patterns-and-practices-grpc/presentation/_shared/assets/section-panel.png">    </p:cNvPr>
           <p:cNvPicPr>
             <a:picLocks noChangeAspect="1"/>
           </p:cNvPicPr>
@@ -24686,7 +24775,7 @@
       </p:sp>
       <p:pic>
         <p:nvPicPr>
-          <p:cNvPr id="6" name="Image 1" descr="/home/rsedor/Dev/api-patterns-and-practices-grpc/presentation/_shared/assets/redhat-logo-white.png">    </p:cNvPr>
+          <p:cNvPr id="6" name="Image 1" descr="/tmp/pcwork/api-patterns-and-practices-grpc/presentation/_shared/assets/redhat-logo-white.png">    </p:cNvPr>
           <p:cNvPicPr>
             <a:picLocks noChangeAspect="1"/>
           </p:cNvPicPr>
@@ -24774,7 +24863,7 @@
       </p:sp>
       <p:pic>
         <p:nvPicPr>
-          <p:cNvPr id="3" name="Image 0" descr="/home/rsedor/Dev/api-patterns-and-practices-grpc/presentation/_shared/assets/logo-candidate-2.png">    </p:cNvPr>
+          <p:cNvPr id="3" name="Image 0" descr="/tmp/pcwork/api-patterns-and-practices-grpc/presentation/_shared/assets/logo-candidate-2.png">    </p:cNvPr>
           <p:cNvPicPr>
             <a:picLocks noChangeAspect="1"/>
           </p:cNvPicPr>
@@ -24876,7 +24965,7 @@
       </p:sp>
       <p:pic>
         <p:nvPicPr>
-          <p:cNvPr id="6" name="Image 1" descr="/home/rsedor/Dev/api-patterns-and-practices-grpc/presentation/_shared/png/27-final-project-architecture.png">    </p:cNvPr>
+          <p:cNvPr id="6" name="Image 1" descr="/tmp/pcwork/api-patterns-and-practices-grpc/presentation/_shared/png/27-final-project-architecture.png">    </p:cNvPr>
           <p:cNvPicPr>
             <a:picLocks noChangeAspect="1"/>
           </p:cNvPicPr>
@@ -25002,7 +25091,7 @@
       </p:sp>
       <p:pic>
         <p:nvPicPr>
-          <p:cNvPr id="3" name="Image 0" descr="/home/rsedor/Dev/api-patterns-and-practices-grpc/presentation/_shared/assets/logo-candidate-2.png">    </p:cNvPr>
+          <p:cNvPr id="3" name="Image 0" descr="/tmp/pcwork/api-patterns-and-practices-grpc/presentation/_shared/assets/logo-candidate-2.png">    </p:cNvPr>
           <p:cNvPicPr>
             <a:picLocks noChangeAspect="1"/>
           </p:cNvPicPr>
@@ -25624,7 +25713,7 @@
       </p:grpSpPr>
       <p:pic>
         <p:nvPicPr>
-          <p:cNvPr id="2" name="Image 0" descr="/home/rsedor/Dev/api-patterns-and-practices-grpc/presentation/_shared/assets/section-panel.png">    </p:cNvPr>
+          <p:cNvPr id="2" name="Image 0" descr="/tmp/pcwork/api-patterns-and-practices-grpc/presentation/_shared/assets/section-panel.png">    </p:cNvPr>
           <p:cNvPicPr>
             <a:picLocks noChangeAspect="1"/>
           </p:cNvPicPr>
@@ -25765,7 +25854,7 @@
       </p:sp>
       <p:pic>
         <p:nvPicPr>
-          <p:cNvPr id="6" name="Image 1" descr="/home/rsedor/Dev/api-patterns-and-practices-grpc/presentation/_shared/assets/redhat-logo-white.png">    </p:cNvPr>
+          <p:cNvPr id="6" name="Image 1" descr="/tmp/pcwork/api-patterns-and-practices-grpc/presentation/_shared/assets/redhat-logo-white.png">    </p:cNvPr>
           <p:cNvPicPr>
             <a:picLocks noChangeAspect="1"/>
           </p:cNvPicPr>
@@ -25853,7 +25942,7 @@
       </p:sp>
       <p:pic>
         <p:nvPicPr>
-          <p:cNvPr id="3" name="Image 0" descr="/home/rsedor/Dev/api-patterns-and-practices-grpc/presentation/_shared/assets/logo-candidate-2.png">    </p:cNvPr>
+          <p:cNvPr id="3" name="Image 0" descr="/tmp/pcwork/api-patterns-and-practices-grpc/presentation/_shared/assets/logo-candidate-2.png">    </p:cNvPr>
           <p:cNvPicPr>
             <a:picLocks noChangeAspect="1"/>
           </p:cNvPicPr>
@@ -26303,7 +26392,7 @@
       </p:sp>
       <p:pic>
         <p:nvPicPr>
-          <p:cNvPr id="3" name="Image 0" descr="/home/rsedor/Dev/api-patterns-and-practices-grpc/presentation/_shared/assets/logo-candidate-2.png">    </p:cNvPr>
+          <p:cNvPr id="3" name="Image 0" descr="/tmp/pcwork/api-patterns-and-practices-grpc/presentation/_shared/assets/logo-candidate-2.png">    </p:cNvPr>
           <p:cNvPicPr>
             <a:picLocks noChangeAspect="1"/>
           </p:cNvPicPr>
@@ -26579,7 +26668,7 @@
       </p:grpSpPr>
       <p:pic>
         <p:nvPicPr>
-          <p:cNvPr id="2" name="Image 0" descr="/home/rsedor/Dev/api-patterns-and-practices-grpc/presentation/_shared/assets/section-panel.png">    </p:cNvPr>
+          <p:cNvPr id="2" name="Image 0" descr="/tmp/pcwork/api-patterns-and-practices-grpc/presentation/_shared/assets/section-panel.png">    </p:cNvPr>
           <p:cNvPicPr>
             <a:picLocks noChangeAspect="1"/>
           </p:cNvPicPr>
@@ -26720,7 +26809,7 @@
       </p:sp>
       <p:pic>
         <p:nvPicPr>
-          <p:cNvPr id="6" name="Image 1" descr="/home/rsedor/Dev/api-patterns-and-practices-grpc/presentation/_shared/assets/redhat-logo-white.png">    </p:cNvPr>
+          <p:cNvPr id="6" name="Image 1" descr="/tmp/pcwork/api-patterns-and-practices-grpc/presentation/_shared/assets/redhat-logo-white.png">    </p:cNvPr>
           <p:cNvPicPr>
             <a:picLocks noChangeAspect="1"/>
           </p:cNvPicPr>
@@ -26808,7 +26897,7 @@
       </p:sp>
       <p:pic>
         <p:nvPicPr>
-          <p:cNvPr id="3" name="Image 0" descr="/home/rsedor/Dev/api-patterns-and-practices-grpc/presentation/_shared/assets/logo-candidate-2.png">    </p:cNvPr>
+          <p:cNvPr id="3" name="Image 0" descr="/tmp/pcwork/api-patterns-and-practices-grpc/presentation/_shared/assets/logo-candidate-2.png">    </p:cNvPr>
           <p:cNvPicPr>
             <a:picLocks noChangeAspect="1"/>
           </p:cNvPicPr>
@@ -27316,7 +27405,7 @@
       </p:sp>
       <p:pic>
         <p:nvPicPr>
-          <p:cNvPr id="3" name="Image 0" descr="/home/rsedor/Dev/api-patterns-and-practices-grpc/presentation/_shared/assets/logo-candidate-2.png">    </p:cNvPr>
+          <p:cNvPr id="3" name="Image 0" descr="/tmp/pcwork/api-patterns-and-practices-grpc/presentation/_shared/assets/logo-candidate-2.png">    </p:cNvPr>
           <p:cNvPicPr>
             <a:picLocks noChangeAspect="1"/>
           </p:cNvPicPr>
@@ -28024,7 +28113,7 @@
       </p:sp>
       <p:pic>
         <p:nvPicPr>
-          <p:cNvPr id="3" name="Image 0" descr="/home/rsedor/Dev/api-patterns-and-practices-grpc/presentation/_shared/assets/logo-candidate-2.png">    </p:cNvPr>
+          <p:cNvPr id="3" name="Image 0" descr="/tmp/pcwork/api-patterns-and-practices-grpc/presentation/_shared/assets/logo-candidate-2.png">    </p:cNvPr>
           <p:cNvPicPr>
             <a:picLocks noChangeAspect="1"/>
           </p:cNvPicPr>
@@ -28750,7 +28839,7 @@
       </p:sp>
       <p:pic>
         <p:nvPicPr>
-          <p:cNvPr id="3" name="Image 0" descr="/home/rsedor/Dev/api-patterns-and-practices-grpc/presentation/_shared/assets/logo-candidate-2.png">    </p:cNvPr>
+          <p:cNvPr id="3" name="Image 0" descr="/tmp/pcwork/api-patterns-and-practices-grpc/presentation/_shared/assets/logo-candidate-2.png">    </p:cNvPr>
           <p:cNvPicPr>
             <a:picLocks noChangeAspect="1"/>
           </p:cNvPicPr>
@@ -29512,7 +29601,7 @@
       </p:sp>
       <p:pic>
         <p:nvPicPr>
-          <p:cNvPr id="3" name="Image 0" descr="/home/rsedor/Dev/api-patterns-and-practices-grpc/presentation/_shared/assets/logo-candidate-2.png">    </p:cNvPr>
+          <p:cNvPr id="3" name="Image 0" descr="/tmp/pcwork/api-patterns-and-practices-grpc/presentation/_shared/assets/logo-candidate-2.png">    </p:cNvPr>
           <p:cNvPicPr>
             <a:picLocks noChangeAspect="1"/>
           </p:cNvPicPr>
@@ -30076,7 +30165,7 @@
       </p:sp>
       <p:pic>
         <p:nvPicPr>
-          <p:cNvPr id="3" name="Image 0" descr="/home/rsedor/Dev/api-patterns-and-practices-grpc/presentation/_shared/assets/logo-candidate-2.png">    </p:cNvPr>
+          <p:cNvPr id="3" name="Image 0" descr="/tmp/pcwork/api-patterns-and-practices-grpc/presentation/_shared/assets/logo-candidate-2.png">    </p:cNvPr>
           <p:cNvPicPr>
             <a:picLocks noChangeAspect="1"/>
           </p:cNvPicPr>
@@ -30658,7 +30747,7 @@
       </p:sp>
       <p:pic>
         <p:nvPicPr>
-          <p:cNvPr id="3" name="Image 0" descr="/home/rsedor/Dev/api-patterns-and-practices-grpc/presentation/_shared/assets/logo-candidate-2.png">    </p:cNvPr>
+          <p:cNvPr id="3" name="Image 0" descr="/tmp/pcwork/api-patterns-and-practices-grpc/presentation/_shared/assets/logo-candidate-2.png">    </p:cNvPr>
           <p:cNvPicPr>
             <a:picLocks noChangeAspect="1"/>
           </p:cNvPicPr>
@@ -31240,7 +31329,7 @@
       </p:sp>
       <p:pic>
         <p:nvPicPr>
-          <p:cNvPr id="3" name="Image 0" descr="/home/rsedor/Dev/api-patterns-and-practices-grpc/presentation/_shared/assets/logo-candidate-2.png">    </p:cNvPr>
+          <p:cNvPr id="3" name="Image 0" descr="/tmp/pcwork/api-patterns-and-practices-grpc/presentation/_shared/assets/logo-candidate-2.png">    </p:cNvPr>
           <p:cNvPicPr>
             <a:picLocks noChangeAspect="1"/>
           </p:cNvPicPr>
@@ -32020,7 +32109,7 @@
       </p:sp>
       <p:pic>
         <p:nvPicPr>
-          <p:cNvPr id="3" name="Image 0" descr="/home/rsedor/Dev/api-patterns-and-practices-grpc/presentation/_shared/assets/logo-candidate-2.png">    </p:cNvPr>
+          <p:cNvPr id="3" name="Image 0" descr="/tmp/pcwork/api-patterns-and-practices-grpc/presentation/_shared/assets/logo-candidate-2.png">    </p:cNvPr>
           <p:cNvPicPr>
             <a:picLocks noChangeAspect="1"/>
           </p:cNvPicPr>
@@ -32328,7 +32417,7 @@
       </p:sp>
       <p:pic>
         <p:nvPicPr>
-          <p:cNvPr id="3" name="Image 0" descr="/home/rsedor/Dev/api-patterns-and-practices-grpc/presentation/_shared/assets/logo-candidate-2.png">    </p:cNvPr>
+          <p:cNvPr id="3" name="Image 0" descr="/tmp/pcwork/api-patterns-and-practices-grpc/presentation/_shared/assets/logo-candidate-2.png">    </p:cNvPr>
           <p:cNvPicPr>
             <a:picLocks noChangeAspect="1"/>
           </p:cNvPicPr>
@@ -32543,6 +32632,454 @@
               <a:t>This deck does not claim a Python run against OpenShift Local that hasn't been built; see the Quarkus sibling deck for the verified CRC walkthrough.</a:t>
             </a:r>
             <a:endParaRPr lang="en-US" sz="1500" dirty="0"/>
+          </a:p>
+        </p:txBody>
+      </p:sp>
+    </p:spTree>
+  </p:cSld>
+  <p:clrMapOvr>
+    <a:masterClrMapping/>
+  </p:clrMapOvr>
+</p:sld>
+</file>
+
+<file path=ppt/slides/slide69.xml><?xml version="1.0" encoding="utf-8"?>
+<p:sld xmlns:a="http://schemas.openxmlformats.org/drawingml/2006/main" xmlns:r="http://schemas.openxmlformats.org/officeDocument/2006/relationships" xmlns:p="http://schemas.openxmlformats.org/presentationml/2006/main">
+  <p:cSld name="Slide 69">
+    <p:spTree>
+      <p:nvGrpSpPr>
+        <p:cNvPr id="1" name=""/>
+        <p:cNvGrpSpPr/>
+        <p:nvPr/>
+      </p:nvGrpSpPr>
+      <p:grpSpPr>
+        <a:xfrm>
+          <a:off x="0" y="0"/>
+          <a:ext cx="0" cy="0"/>
+          <a:chOff x="0" y="0"/>
+          <a:chExt cx="0" cy="0"/>
+        </a:xfrm>
+      </p:grpSpPr>
+      <p:sp>
+        <p:nvSpPr>
+          <p:cNvPr id="2" name="Text 0"/>
+          <p:cNvSpPr/>
+          <p:nvPr/>
+        </p:nvSpPr>
+        <p:spPr>
+          <a:xfrm>
+            <a:off x="566928" y="6364224"/>
+            <a:ext cx="914400" cy="274320"/>
+          </a:xfrm>
+          <a:prstGeom prst="rect">
+            <a:avLst/>
+          </a:prstGeom>
+          <a:noFill/>
+          <a:ln/>
+        </p:spPr>
+        <p:txBody>
+          <a:bodyPr wrap="square" rtlCol="0" anchor="ctr"/>
+          <a:lstStyle/>
+          <a:p>
+            <a:pPr algn="l" indent="0" marL="0">
+              <a:buNone/>
+            </a:pPr>
+            <a:r>
+              <a:rPr lang="en-US" sz="1000" dirty="0">
+                <a:solidFill>
+                  <a:srgbClr val="8A8A8A"/>
+                </a:solidFill>
+                <a:latin typeface="Red Hat Text" pitchFamily="34" charset="0"/>
+                <a:ea typeface="Red Hat Text" pitchFamily="34" charset="-122"/>
+                <a:cs typeface="Red Hat Text" pitchFamily="34" charset="-120"/>
+              </a:rPr>
+              <a:t>69</a:t>
+            </a:r>
+            <a:endParaRPr lang="en-US" sz="1000" dirty="0"/>
+          </a:p>
+        </p:txBody>
+      </p:sp>
+      <p:pic>
+        <p:nvPicPr>
+          <p:cNvPr id="3" name="Image 0" descr="/tmp/pcwork/api-patterns-and-practices-grpc/presentation/_shared/assets/logo-candidate-2.png">    </p:cNvPr>
+          <p:cNvPicPr>
+            <a:picLocks noChangeAspect="1"/>
+          </p:cNvPicPr>
+          <p:nvPr/>
+        </p:nvPicPr>
+        <p:blipFill>
+          <a:blip r:embed="rId1"/>
+          <a:stretch>
+            <a:fillRect/>
+          </a:stretch>
+        </p:blipFill>
+        <p:spPr>
+          <a:xfrm>
+            <a:off x="10561320" y="6355080"/>
+            <a:ext cx="1033272" cy="246888"/>
+          </a:xfrm>
+          <a:prstGeom prst="rect">
+            <a:avLst/>
+          </a:prstGeom>
+        </p:spPr>
+      </p:pic>
+      <p:sp>
+        <p:nvSpPr>
+          <p:cNvPr id="4" name="Text 1"/>
+          <p:cNvSpPr/>
+          <p:nvPr/>
+        </p:nvSpPr>
+        <p:spPr>
+          <a:xfrm>
+            <a:off x="566928" y="384048"/>
+            <a:ext cx="11055096" cy="292608"/>
+          </a:xfrm>
+          <a:prstGeom prst="rect">
+            <a:avLst/>
+          </a:prstGeom>
+          <a:noFill/>
+          <a:ln/>
+        </p:spPr>
+        <p:txBody>
+          <a:bodyPr wrap="square" rtlCol="0" anchor="ctr"/>
+          <a:lstStyle/>
+          <a:p>
+            <a:pPr algn="l" indent="0" marL="0">
+              <a:buNone/>
+            </a:pPr>
+            <a:r>
+              <a:rPr lang="en-US" sz="1200" b="1" spc="400" kern="0" dirty="0">
+                <a:solidFill>
+                  <a:srgbClr val="EE0000"/>
+                </a:solidFill>
+                <a:latin typeface="Overpass" pitchFamily="34" charset="0"/>
+                <a:ea typeface="Overpass" pitchFamily="34" charset="-122"/>
+                <a:cs typeface="Overpass" pitchFamily="34" charset="-120"/>
+              </a:rPr>
+              <a:t>SCAN TO EXPLORE</a:t>
+            </a:r>
+            <a:endParaRPr lang="en-US" sz="1200" dirty="0"/>
+          </a:p>
+        </p:txBody>
+      </p:sp>
+      <p:sp>
+        <p:nvSpPr>
+          <p:cNvPr id="5" name="Text 2"/>
+          <p:cNvSpPr/>
+          <p:nvPr/>
+        </p:nvSpPr>
+        <p:spPr>
+          <a:xfrm>
+            <a:off x="566928" y="676656"/>
+            <a:ext cx="11055096" cy="1005840"/>
+          </a:xfrm>
+          <a:prstGeom prst="rect">
+            <a:avLst/>
+          </a:prstGeom>
+          <a:noFill/>
+          <a:ln/>
+        </p:spPr>
+        <p:txBody>
+          <a:bodyPr wrap="square" rtlCol="0" anchor="t"/>
+          <a:lstStyle/>
+          <a:p>
+            <a:pPr algn="l" indent="0" marL="0">
+              <a:buNone/>
+            </a:pPr>
+            <a:r>
+              <a:rPr lang="en-US" sz="3000" b="1" dirty="0">
+                <a:solidFill>
+                  <a:srgbClr val="151515"/>
+                </a:solidFill>
+                <a:latin typeface="Overpass" pitchFamily="34" charset="0"/>
+                <a:ea typeface="Overpass" pitchFamily="34" charset="-122"/>
+                <a:cs typeface="Overpass" pitchFamily="34" charset="-120"/>
+              </a:rPr>
+              <a:t>Take it with you</a:t>
+            </a:r>
+            <a:endParaRPr lang="en-US" sz="3000" dirty="0"/>
+          </a:p>
+        </p:txBody>
+      </p:sp>
+      <p:pic>
+        <p:nvPicPr>
+          <p:cNvPr id="6" name="Image 1" descr="/tmp/pcwork/api-patterns-and-practices-grpc/presentation/_shared/assets/qr-grpc-site.png">    </p:cNvPr>
+          <p:cNvPicPr>
+            <a:picLocks noChangeAspect="1"/>
+          </p:cNvPicPr>
+          <p:nvPr/>
+        </p:nvPicPr>
+        <p:blipFill>
+          <a:blip r:embed="rId2"/>
+          <a:stretch>
+            <a:fillRect/>
+          </a:stretch>
+        </p:blipFill>
+        <p:spPr>
+          <a:xfrm>
+            <a:off x="2103120" y="1627632"/>
+            <a:ext cx="2834640" cy="2834640"/>
+          </a:xfrm>
+          <a:prstGeom prst="rect">
+            <a:avLst/>
+          </a:prstGeom>
+        </p:spPr>
+      </p:pic>
+      <p:sp>
+        <p:nvSpPr>
+          <p:cNvPr id="7" name="Text 3"/>
+          <p:cNvSpPr/>
+          <p:nvPr/>
+        </p:nvSpPr>
+        <p:spPr>
+          <a:xfrm>
+            <a:off x="1417320" y="4553712"/>
+            <a:ext cx="4206240" cy="365760"/>
+          </a:xfrm>
+          <a:prstGeom prst="rect">
+            <a:avLst/>
+          </a:prstGeom>
+          <a:noFill/>
+          <a:ln/>
+        </p:spPr>
+        <p:txBody>
+          <a:bodyPr wrap="square" rtlCol="0" anchor="ctr"/>
+          <a:lstStyle/>
+          <a:p>
+            <a:pPr algn="ctr" indent="0" marL="0">
+              <a:buNone/>
+            </a:pPr>
+            <a:r>
+              <a:rPr lang="en-US" sz="1800" b="1" dirty="0">
+                <a:solidFill>
+                  <a:srgbClr val="151515"/>
+                </a:solidFill>
+                <a:latin typeface="Overpass" pitchFamily="34" charset="0"/>
+                <a:ea typeface="Overpass" pitchFamily="34" charset="-122"/>
+                <a:cs typeface="Overpass" pitchFamily="34" charset="-120"/>
+              </a:rPr>
+              <a:t>The site</a:t>
+            </a:r>
+            <a:endParaRPr lang="en-US" sz="1800" dirty="0"/>
+          </a:p>
+        </p:txBody>
+      </p:sp>
+      <p:sp>
+        <p:nvSpPr>
+          <p:cNvPr id="8" name="Text 4"/>
+          <p:cNvSpPr/>
+          <p:nvPr/>
+        </p:nvSpPr>
+        <p:spPr>
+          <a:xfrm>
+            <a:off x="1325880" y="4937760"/>
+            <a:ext cx="4389120" cy="658368"/>
+          </a:xfrm>
+          <a:prstGeom prst="rect">
+            <a:avLst/>
+          </a:prstGeom>
+          <a:noFill/>
+          <a:ln/>
+        </p:spPr>
+        <p:txBody>
+          <a:bodyPr wrap="square" rtlCol="0" anchor="t"/>
+          <a:lstStyle/>
+          <a:p>
+            <a:pPr algn="ctr" indent="0" marL="0">
+              <a:buNone/>
+            </a:pPr>
+            <a:r>
+              <a:rPr lang="en-US" sz="1300" i="1" dirty="0">
+                <a:solidFill>
+                  <a:srgbClr val="5A5A5A"/>
+                </a:solidFill>
+                <a:latin typeface="Red Hat Text" pitchFamily="34" charset="0"/>
+                <a:ea typeface="Red Hat Text" pitchFamily="34" charset="-122"/>
+                <a:cs typeface="Red Hat Text" pitchFamily="34" charset="-120"/>
+              </a:rPr>
+              <a:t>Chapters, the Protobuf contracts, and both-stack runnable examples</a:t>
+            </a:r>
+            <a:endParaRPr lang="en-US" sz="1300" dirty="0"/>
+          </a:p>
+        </p:txBody>
+      </p:sp>
+      <p:sp>
+        <p:nvSpPr>
+          <p:cNvPr id="9" name="Text 5"/>
+          <p:cNvSpPr/>
+          <p:nvPr/>
+        </p:nvSpPr>
+        <p:spPr>
+          <a:xfrm>
+            <a:off x="1325880" y="5596128"/>
+            <a:ext cx="4389120" cy="292608"/>
+          </a:xfrm>
+          <a:prstGeom prst="rect">
+            <a:avLst/>
+          </a:prstGeom>
+          <a:noFill/>
+          <a:ln/>
+        </p:spPr>
+        <p:txBody>
+          <a:bodyPr wrap="square" rtlCol="0" anchor="ctr"/>
+          <a:lstStyle/>
+          <a:p>
+            <a:pPr algn="ctr" indent="0" marL="0">
+              <a:buNone/>
+            </a:pPr>
+            <a:r>
+              <a:rPr lang="en-US" sz="1000" dirty="0">
+                <a:solidFill>
+                  <a:srgbClr val="EE0000"/>
+                </a:solidFill>
+                <a:latin typeface="Red Hat Mono" pitchFamily="34" charset="0"/>
+                <a:ea typeface="Red Hat Mono" pitchFamily="34" charset="-122"/>
+                <a:cs typeface="Red Hat Mono" pitchFamily="34" charset="-120"/>
+              </a:rPr>
+              <a:t>patterncatalyst.github.io/api-patterns-and-practices-grpc</a:t>
+            </a:r>
+            <a:endParaRPr lang="en-US" sz="1000" dirty="0"/>
+          </a:p>
+        </p:txBody>
+      </p:sp>
+      <p:pic>
+        <p:nvPicPr>
+          <p:cNvPr id="10" name="Image 2" descr="/tmp/pcwork/api-patterns-and-practices-grpc/presentation/_shared/assets/qr-hub.png">    </p:cNvPr>
+          <p:cNvPicPr>
+            <a:picLocks noChangeAspect="1"/>
+          </p:cNvPicPr>
+          <p:nvPr/>
+        </p:nvPicPr>
+        <p:blipFill>
+          <a:blip r:embed="rId3"/>
+          <a:stretch>
+            <a:fillRect/>
+          </a:stretch>
+        </p:blipFill>
+        <p:spPr>
+          <a:xfrm>
+            <a:off x="7251192" y="1627632"/>
+            <a:ext cx="2834640" cy="2834640"/>
+          </a:xfrm>
+          <a:prstGeom prst="rect">
+            <a:avLst/>
+          </a:prstGeom>
+        </p:spPr>
+      </p:pic>
+      <p:sp>
+        <p:nvSpPr>
+          <p:cNvPr id="11" name="Text 6"/>
+          <p:cNvSpPr/>
+          <p:nvPr/>
+        </p:nvSpPr>
+        <p:spPr>
+          <a:xfrm>
+            <a:off x="6565392" y="4553712"/>
+            <a:ext cx="4206240" cy="365760"/>
+          </a:xfrm>
+          <a:prstGeom prst="rect">
+            <a:avLst/>
+          </a:prstGeom>
+          <a:noFill/>
+          <a:ln/>
+        </p:spPr>
+        <p:txBody>
+          <a:bodyPr wrap="square" rtlCol="0" anchor="ctr"/>
+          <a:lstStyle/>
+          <a:p>
+            <a:pPr algn="ctr" indent="0" marL="0">
+              <a:buNone/>
+            </a:pPr>
+            <a:r>
+              <a:rPr lang="en-US" sz="1800" b="1" dirty="0">
+                <a:solidFill>
+                  <a:srgbClr val="151515"/>
+                </a:solidFill>
+                <a:latin typeface="Overpass" pitchFamily="34" charset="0"/>
+                <a:ea typeface="Overpass" pitchFamily="34" charset="-122"/>
+                <a:cs typeface="Overpass" pitchFamily="34" charset="-120"/>
+              </a:rPr>
+              <a:t>Workshops &amp; Tutorials</a:t>
+            </a:r>
+            <a:endParaRPr lang="en-US" sz="1800" dirty="0"/>
+          </a:p>
+        </p:txBody>
+      </p:sp>
+      <p:sp>
+        <p:nvSpPr>
+          <p:cNvPr id="12" name="Text 7"/>
+          <p:cNvSpPr/>
+          <p:nvPr/>
+        </p:nvSpPr>
+        <p:spPr>
+          <a:xfrm>
+            <a:off x="6473952" y="4937760"/>
+            <a:ext cx="4389120" cy="658368"/>
+          </a:xfrm>
+          <a:prstGeom prst="rect">
+            <a:avLst/>
+          </a:prstGeom>
+          <a:noFill/>
+          <a:ln/>
+        </p:spPr>
+        <p:txBody>
+          <a:bodyPr wrap="square" rtlCol="0" anchor="t"/>
+          <a:lstStyle/>
+          <a:p>
+            <a:pPr algn="ctr" indent="0" marL="0">
+              <a:buNone/>
+            </a:pPr>
+            <a:r>
+              <a:rPr lang="en-US" sz="1300" i="1" dirty="0">
+                <a:solidFill>
+                  <a:srgbClr val="5A5A5A"/>
+                </a:solidFill>
+                <a:latin typeface="Red Hat Text" pitchFamily="34" charset="0"/>
+                <a:ea typeface="Red Hat Text" pitchFamily="34" charset="-122"/>
+                <a:cs typeface="Red Hat Text" pitchFamily="34" charset="-120"/>
+              </a:rPr>
+              <a:t>The whole series: every workshop, tutorial, and deck in one place</a:t>
+            </a:r>
+            <a:endParaRPr lang="en-US" sz="1300" dirty="0"/>
+          </a:p>
+        </p:txBody>
+      </p:sp>
+      <p:sp>
+        <p:nvSpPr>
+          <p:cNvPr id="13" name="Text 8"/>
+          <p:cNvSpPr/>
+          <p:nvPr/>
+        </p:nvSpPr>
+        <p:spPr>
+          <a:xfrm>
+            <a:off x="6473952" y="5596128"/>
+            <a:ext cx="4389120" cy="292608"/>
+          </a:xfrm>
+          <a:prstGeom prst="rect">
+            <a:avLst/>
+          </a:prstGeom>
+          <a:noFill/>
+          <a:ln/>
+        </p:spPr>
+        <p:txBody>
+          <a:bodyPr wrap="square" rtlCol="0" anchor="ctr"/>
+          <a:lstStyle/>
+          <a:p>
+            <a:pPr algn="ctr" indent="0" marL="0">
+              <a:buNone/>
+            </a:pPr>
+            <a:r>
+              <a:rPr lang="en-US" sz="900" dirty="0">
+                <a:solidFill>
+                  <a:srgbClr val="EE0000"/>
+                </a:solidFill>
+                <a:latin typeface="Red Hat Mono" pitchFamily="34" charset="0"/>
+                <a:ea typeface="Red Hat Mono" pitchFamily="34" charset="-122"/>
+                <a:cs typeface="Red Hat Mono" pitchFamily="34" charset="-120"/>
+              </a:rPr>
+              <a:t>patterncatalyst.github.io/patterncatalyst-workshops-tutorials-list</a:t>
+            </a:r>
+            <a:endParaRPr lang="en-US" sz="900" dirty="0"/>
           </a:p>
         </p:txBody>
       </p:sp>
@@ -32580,7 +33117,7 @@
       </p:grpSpPr>
       <p:pic>
         <p:nvPicPr>
-          <p:cNvPr id="2" name="Image 0" descr="/home/rsedor/Dev/api-patterns-and-practices-grpc/presentation/_shared/assets/section-panel.png">    </p:cNvPr>
+          <p:cNvPr id="2" name="Image 0" descr="/tmp/pcwork/api-patterns-and-practices-grpc/presentation/_shared/assets/section-panel.png">    </p:cNvPr>
           <p:cNvPicPr>
             <a:picLocks noChangeAspect="1"/>
           </p:cNvPicPr>
@@ -32721,7 +33258,7 @@
       </p:sp>
       <p:pic>
         <p:nvPicPr>
-          <p:cNvPr id="6" name="Image 1" descr="/home/rsedor/Dev/api-patterns-and-practices-grpc/presentation/_shared/assets/redhat-logo-white.png">    </p:cNvPr>
+          <p:cNvPr id="6" name="Image 1" descr="/tmp/pcwork/api-patterns-and-practices-grpc/presentation/_shared/assets/redhat-logo-white.png">    </p:cNvPr>
           <p:cNvPicPr>
             <a:picLocks noChangeAspect="1"/>
           </p:cNvPicPr>
@@ -32809,7 +33346,7 @@
       </p:sp>
       <p:pic>
         <p:nvPicPr>
-          <p:cNvPr id="3" name="Image 0" descr="/home/rsedor/Dev/api-patterns-and-practices-grpc/presentation/_shared/assets/logo-candidate-2.png">    </p:cNvPr>
+          <p:cNvPr id="3" name="Image 0" descr="/tmp/pcwork/api-patterns-and-practices-grpc/presentation/_shared/assets/logo-candidate-2.png">    </p:cNvPr>
           <p:cNvPicPr>
             <a:picLocks noChangeAspect="1"/>
           </p:cNvPicPr>
@@ -32911,7 +33448,7 @@
       </p:sp>
       <p:pic>
         <p:nvPicPr>
-          <p:cNvPr id="6" name="Image 1" descr="/home/rsedor/Dev/api-patterns-and-practices-grpc/presentation/_shared/png/04-wellknown-json-mapping.png">    </p:cNvPr>
+          <p:cNvPr id="6" name="Image 1" descr="/tmp/pcwork/api-patterns-and-practices-grpc/presentation/_shared/png/04-wellknown-json-mapping.png">    </p:cNvPr>
           <p:cNvPicPr>
             <a:picLocks noChangeAspect="1"/>
           </p:cNvPicPr>
@@ -33037,7 +33574,7 @@
       </p:sp>
       <p:pic>
         <p:nvPicPr>
-          <p:cNvPr id="3" name="Image 0" descr="/home/rsedor/Dev/api-patterns-and-practices-grpc/presentation/_shared/assets/logo-candidate-2.png">    </p:cNvPr>
+          <p:cNvPr id="3" name="Image 0" descr="/tmp/pcwork/api-patterns-and-practices-grpc/presentation/_shared/assets/logo-candidate-2.png">    </p:cNvPr>
           <p:cNvPicPr>
             <a:picLocks noChangeAspect="1"/>
           </p:cNvPicPr>

</xml_diff>